<commit_message>
pm-method 2.5.0: guías de instalación WSL2 y Docker verificadas, diagram-design opcional e Informe 2 v2.5
</commit_message>
<xml_diff>
--- a/docs/ieee/pm-method-ieee-informe-light.pptx
+++ b/docs/ieee/pm-method-ieee-informe-light.pptx
@@ -1559,7 +1559,7 @@
                   <a:srgbClr val="696969"/>
                 </a:solidFill>
               </a:rPr>
-              <a:t>pm-method 2.4.0 · Informe 2 en versión light para IEEE</a:t>
+              <a:t>pm-method 2.5.0 · Informe 2 en versión light para IEEE</a:t>
             </a:r>
             <a:endParaRPr lang="en-US" sz="900" dirty="0"/>
           </a:p>
@@ -2394,7 +2394,7 @@
                   <a:srgbClr val="9FD0F0"/>
                 </a:solidFill>
               </a:rPr>
-              <a:t>pm-method 2.4.0 · resumen del Informe 2 (documentación del ecosistema)</a:t>
+              <a:t>pm-method 2.5.0 · resumen del Informe 2 (documentación del ecosistema)</a:t>
             </a:r>
             <a:endParaRPr lang="en-US" sz="1100" dirty="0"/>
           </a:p>
@@ -9128,7 +9128,7 @@
                   <a:srgbClr val="FFFFFF"/>
                 </a:solidFill>
               </a:rPr>
-              <a:t>Calidad verificada (2026-10-22): 346 pruebas automáticas sin fallos y 5 recorridos completos reproducibles</a:t>
+              <a:t>Calidad verificada (2026-10-27): 355 pruebas automáticas sin fallos y 5 recorridos completos reproducibles</a:t>
             </a:r>
             <a:endParaRPr lang="en-US" sz="1400" dirty="0"/>
           </a:p>

</xml_diff>

<commit_message>
pm-method 2.6.0: decisiones con contexto, vigencia y bitácora, mapas y decisiones, y pm-kb (búsqueda citada, web y MCP)
</commit_message>
<xml_diff>
--- a/docs/ieee/pm-method-ieee-informe-light.pptx
+++ b/docs/ieee/pm-method-ieee-informe-light.pptx
@@ -14,9 +14,10 @@
     <p:sldId id="262" r:id="rId8"/>
     <p:sldId id="263" r:id="rId9"/>
     <p:sldId id="264" r:id="rId10"/>
+    <p:sldId id="265" r:id="rId11"/>
   </p:sldIdLst>
   <p:notesMasterIdLst>
-    <p:notesMasterId r:id="rId11"/>
+    <p:notesMasterId r:id="rId12"/>
   </p:notesMasterIdLst>
   <p:sldSz cx="12192000" cy="6858000"/>
   <p:notesSz cx="6858000" cy="12192000"/>
@@ -552,6 +553,94 @@
 </p:notes>
 </file>
 
+<file path=ppt/notesSlides/notesSlide10.xml><?xml version="1.0" encoding="utf-8"?>
+<p:notes xmlns:a="http://schemas.openxmlformats.org/drawingml/2006/main" xmlns:r="http://schemas.openxmlformats.org/officeDocument/2006/relationships" xmlns:p="http://schemas.openxmlformats.org/presentationml/2006/main">
+  <p:cSld>
+    <p:spTree>
+      <p:nvGrpSpPr>
+        <p:cNvPr id="1" name=""/>
+        <p:cNvGrpSpPr/>
+        <p:nvPr/>
+      </p:nvGrpSpPr>
+      <p:grpSpPr>
+        <a:xfrm>
+          <a:off x="0" y="0"/>
+          <a:ext cx="0" cy="0"/>
+          <a:chOff x="0" y="0"/>
+          <a:chExt cx="0" cy="0"/>
+        </a:xfrm>
+      </p:grpSpPr>
+      <p:sp>
+        <p:nvSpPr>
+          <p:cNvPr id="2" name="Slide Image Placeholder 1"/>
+          <p:cNvSpPr>
+            <a:spLocks noGrp="1" noRot="1" noChangeAspect="1"/>
+          </p:cNvSpPr>
+          <p:nvPr>
+            <p:ph type="sldImg"/>
+          </p:nvPr>
+        </p:nvSpPr>
+        <p:spPr/>
+      </p:sp>
+      <p:sp>
+        <p:nvSpPr>
+          <p:cNvPr id="3" name="Notes Placeholder 2"/>
+          <p:cNvSpPr>
+            <a:spLocks noGrp="1"/>
+          </p:cNvSpPr>
+          <p:nvPr>
+            <p:ph type="body" idx="1"/>
+          </p:nvPr>
+        </p:nvSpPr>
+        <p:spPr/>
+        <p:txBody>
+          <a:bodyPr/>
+          <a:lstStyle/>
+          <a:p>
+            <a:r>
+              <a:rPr lang="en-US" dirty="0"/>
+              <a:t>El informe completo es explícito sobre lo que falta: un piloto real con personas no técnicas y pruebas con servicios externos reales. Lo que sí está listo es el material para aprender: cinco casos de práctica con guía, ejercicio y diapositivas. El siguiente paso propuesto es un piloto de formación corto con IEEE.</a:t>
+            </a:r>
+            <a:endParaRPr lang="en-US" dirty="0"/>
+          </a:p>
+        </p:txBody>
+      </p:sp>
+      <p:sp>
+        <p:nvSpPr>
+          <p:cNvPr id="4" name="Slide Number Placeholder 3"/>
+          <p:cNvSpPr>
+            <a:spLocks noGrp="1"/>
+          </p:cNvSpPr>
+          <p:nvPr>
+            <p:ph type="sldNum" sz="quarter" idx="10"/>
+          </p:nvPr>
+        </p:nvSpPr>
+        <p:spPr/>
+        <p:txBody>
+          <a:bodyPr/>
+          <a:lstStyle/>
+          <a:p>
+            <a:fld id="{F7021451-1387-4CA6-816F-3879F97B5CBC}" type="slidenum">
+              <a:rPr lang="en-US"/>
+              <a:t>10</a:t>
+            </a:fld>
+            <a:endParaRPr lang="en-US"/>
+          </a:p>
+        </p:txBody>
+      </p:sp>
+    </p:spTree>
+    <p:extLst>
+      <p:ext uri="{BB962C8B-B14F-4D97-AF65-F5344CB8AC3E}">
+        <p14:creationId xmlns:p14="http://schemas.microsoft.com/office/powerpoint/2010/main" val="1024086991"/>
+      </p:ext>
+    </p:extLst>
+  </p:cSld>
+  <p:clrMapOvr>
+    <a:masterClrMapping/>
+  </p:clrMapOvr>
+</p:notes>
+</file>
+
 <file path=ppt/notesSlides/notesSlide2.xml><?xml version="1.0" encoding="utf-8"?>
 <p:notes xmlns:a="http://schemas.openxmlformats.org/drawingml/2006/main" xmlns:r="http://schemas.openxmlformats.org/officeDocument/2006/relationships" xmlns:p="http://schemas.openxmlformats.org/presentationml/2006/main">
   <p:cSld>
@@ -1126,7 +1215,7 @@
           <a:p>
             <a:r>
               <a:rPr lang="en-US" dirty="0"/>
-              <a:t>Las ventajas cambian según el rol, pero tienen un denominador común: lo que se decide queda registrado y los números cuadran entre el informe, el tablero y el correo. La línea de calidad resume la evidencia del informe completo. Al ser abierto, nada queda atado al sistema.</a:t>
+              <a:t>Elegir entre alternativas es donde más se improvisa: se decide con lo que uno recuerda y después nadie encuentra en qué se basó. El sistema arma primero un expediente con la evidencia, compara las opciones con criterios explícitos y deja que decida quien tiene la autoridad. Un componente opcional indexa los documentos del proyecto y responde preguntas citando la fuente; nunca escribe en el proyecto.</a:t>
             </a:r>
             <a:endParaRPr lang="en-US" dirty="0"/>
           </a:p>
@@ -1214,7 +1303,7 @@
           <a:p>
             <a:r>
               <a:rPr lang="en-US" dirty="0"/>
-              <a:t>El informe completo es explícito sobre lo que falta: un piloto real con personas no técnicas y pruebas con servicios externos reales. Lo que sí está listo es el material para aprender: cinco casos de práctica con guía, ejercicio y diapositivas. El siguiente paso propuesto es un piloto de formación corto con IEEE.</a:t>
+              <a:t>Las ventajas cambian según el rol, pero tienen un denominador común: lo que se decide queda registrado y los números cuadran entre el informe, el tablero y el correo. La línea de calidad resume la evidencia del informe completo. Al ser abierto, nada queda atado al sistema.</a:t>
             </a:r>
             <a:endParaRPr lang="en-US" dirty="0"/>
           </a:p>
@@ -1559,7 +1648,7 @@
                   <a:srgbClr val="696969"/>
                 </a:solidFill>
               </a:rPr>
-              <a:t>pm-method 2.5.0 · Informe 2 en versión light para IEEE</a:t>
+              <a:t>pm-method 2.6.0 · Informe 2 en versión light para IEEE</a:t>
             </a:r>
             <a:endParaRPr lang="en-US" sz="900" dirty="0"/>
           </a:p>
@@ -2394,9 +2483,1117 @@
                   <a:srgbClr val="9FD0F0"/>
                 </a:solidFill>
               </a:rPr>
-              <a:t>pm-method 2.5.0 · resumen del Informe 2 (documentación del ecosistema)</a:t>
+              <a:t>pm-method 2.6.0 · resumen del Informe 2 (documentación del ecosistema)</a:t>
             </a:r>
             <a:endParaRPr lang="en-US" sz="1100" dirty="0"/>
+          </a:p>
+        </p:txBody>
+      </p:sp>
+    </p:spTree>
+  </p:cSld>
+  <p:clrMapOvr>
+    <a:masterClrMapping/>
+  </p:clrMapOvr>
+</p:sld>
+</file>
+
+<file path=ppt/slides/slide10.xml><?xml version="1.0" encoding="utf-8"?>
+<p:sld xmlns:a="http://schemas.openxmlformats.org/drawingml/2006/main" xmlns:r="http://schemas.openxmlformats.org/officeDocument/2006/relationships" xmlns:p="http://schemas.openxmlformats.org/presentationml/2006/main">
+  <p:cSld name="Slide 10">
+    <p:spTree>
+      <p:nvGrpSpPr>
+        <p:cNvPr id="1" name=""/>
+        <p:cNvGrpSpPr/>
+        <p:nvPr/>
+      </p:nvGrpSpPr>
+      <p:grpSpPr>
+        <a:xfrm>
+          <a:off x="0" y="0"/>
+          <a:ext cx="0" cy="0"/>
+          <a:chOff x="0" y="0"/>
+          <a:chExt cx="0" cy="0"/>
+        </a:xfrm>
+      </p:grpSpPr>
+      <p:sp>
+        <p:nvSpPr>
+          <p:cNvPr id="2" name="Text 3"/>
+          <p:cNvSpPr/>
+          <p:nvPr>
+            <p:ph idx="103" type="title" hasCustomPrompt="1"/>
+          </p:nvPr>
+        </p:nvSpPr>
+        <p:spPr>
+          <a:xfrm>
+            <a:off x="640080" y="365760"/>
+            <a:ext cx="9235440" cy="713232"/>
+          </a:xfrm>
+          <a:prstGeom prst="rect">
+            <a:avLst/>
+          </a:prstGeom>
+          <a:noFill/>
+          <a:ln/>
+        </p:spPr>
+        <p:txBody>
+          <a:bodyPr wrap="square" lIns="0" tIns="0" rIns="0" bIns="0" rtlCol="0" anchor="ctr"/>
+          <a:lstStyle/>
+          <a:p>
+            <a:pPr algn="l" indent="0" marL="0">
+              <a:buNone/>
+            </a:pPr>
+            <a:r>
+              <a:rPr lang="en-US" sz="1900" b="1" dirty="0">
+                <a:solidFill>
+                  <a:srgbClr val="FFFFFF"/>
+                </a:solidFill>
+              </a:rPr>
+              <a:t>Qué falta y cómo seguir: un piloto real, con usuarios y herramientas reales</a:t>
+            </a:r>
+            <a:endParaRPr lang="en-US" sz="1900" dirty="0"/>
+          </a:p>
+        </p:txBody>
+      </p:sp>
+      <p:sp>
+        <p:nvSpPr>
+          <p:cNvPr id="4" name="Shape 1"/>
+          <p:cNvSpPr/>
+          <p:nvPr/>
+        </p:nvSpPr>
+        <p:spPr>
+          <a:xfrm>
+            <a:off x="457200" y="1298448"/>
+            <a:ext cx="5541264" cy="4114800"/>
+          </a:xfrm>
+          <a:prstGeom prst="roundRect">
+            <a:avLst>
+              <a:gd name="adj" fmla="val 1778"/>
+            </a:avLst>
+          </a:prstGeom>
+          <a:solidFill>
+            <a:srgbClr val="F4F6F8"/>
+          </a:solidFill>
+          <a:ln w="9525">
+            <a:solidFill>
+              <a:srgbClr val="F4F6F8"/>
+            </a:solidFill>
+            <a:prstDash val="solid"/>
+          </a:ln>
+        </p:spPr>
+      </p:sp>
+      <p:sp>
+        <p:nvSpPr>
+          <p:cNvPr id="5" name="Text 2"/>
+          <p:cNvSpPr txBox="1"/>
+          <p:nvPr/>
+        </p:nvSpPr>
+        <p:spPr>
+          <a:xfrm>
+            <a:off x="658368" y="1463040"/>
+            <a:ext cx="5175504" cy="256032"/>
+          </a:xfrm>
+          <a:prstGeom prst="rect">
+            <a:avLst/>
+          </a:prstGeom>
+          <a:noFill/>
+          <a:ln/>
+        </p:spPr>
+        <p:txBody>
+          <a:bodyPr wrap="square" lIns="0" tIns="0" rIns="0" bIns="0" rtlCol="0" anchor="t"/>
+          <a:lstStyle/>
+          <a:p>
+            <a:pPr indent="0" marL="0">
+              <a:buNone/>
+            </a:pPr>
+            <a:r>
+              <a:rPr lang="en-US" sz="1100" b="1" spc="100" kern="0" dirty="0">
+                <a:solidFill>
+                  <a:srgbClr val="17324D"/>
+                </a:solidFill>
+              </a:rPr>
+              <a:t>LÍMITES CONOCIDOS, CON HONESTIDAD</a:t>
+            </a:r>
+            <a:endParaRPr lang="en-US" sz="1100" dirty="0"/>
+          </a:p>
+        </p:txBody>
+      </p:sp>
+      <p:sp>
+        <p:nvSpPr>
+          <p:cNvPr id="6" name="Text 3"/>
+          <p:cNvSpPr txBox="1"/>
+          <p:nvPr/>
+        </p:nvSpPr>
+        <p:spPr>
+          <a:xfrm>
+            <a:off x="658368" y="1847088"/>
+            <a:ext cx="5138928" cy="3429000"/>
+          </a:xfrm>
+          <a:prstGeom prst="rect">
+            <a:avLst/>
+          </a:prstGeom>
+          <a:noFill/>
+          <a:ln/>
+        </p:spPr>
+        <p:txBody>
+          <a:bodyPr wrap="square" lIns="0" tIns="0" rIns="0" bIns="0" rtlCol="0" anchor="t"/>
+          <a:lstStyle/>
+          <a:p>
+            <a:pPr indent="0" marL="0">
+              <a:spcAft>
+                <a:spcPts val="1000"/>
+              </a:spcAft>
+              <a:buNone/>
+            </a:pPr>
+            <a:r>
+              <a:rPr lang="en-US" sz="1500" b="1" dirty="0">
+                <a:solidFill>
+                  <a:srgbClr val="B5651D"/>
+                </a:solidFill>
+              </a:rPr>
+              <a:t>▪  </a:t>
+            </a:r>
+            <a:pPr indent="0" marL="0">
+              <a:spcAft>
+                <a:spcPts val="1000"/>
+              </a:spcAft>
+              <a:buNone/>
+            </a:pPr>
+            <a:r>
+              <a:rPr lang="en-US" sz="1500" dirty="0">
+                <a:solidFill>
+                  <a:srgbClr val="272425"/>
+                </a:solidFill>
+              </a:rPr>
+              <a:t>Falta un piloto real con usuarios no técnicos durante varias semanas</a:t>
+            </a:r>
+            <a:endParaRPr lang="en-US" sz="1500" dirty="0"/>
+          </a:p>
+          <a:p>
+            <a:pPr indent="0" marL="0">
+              <a:spcAft>
+                <a:spcPts val="1000"/>
+              </a:spcAft>
+              <a:buNone/>
+            </a:pPr>
+            <a:r>
+              <a:rPr lang="en-US" sz="1500" b="1" dirty="0">
+                <a:solidFill>
+                  <a:srgbClr val="B5651D"/>
+                </a:solidFill>
+              </a:rPr>
+              <a:t>▪  </a:t>
+            </a:r>
+            <a:pPr indent="0" marL="0">
+              <a:spcAft>
+                <a:spcPts val="1000"/>
+              </a:spcAft>
+              <a:buNone/>
+            </a:pPr>
+            <a:r>
+              <a:rPr lang="en-US" sz="1500" dirty="0">
+                <a:solidFill>
+                  <a:srgbClr val="272425"/>
+                </a:solidFill>
+              </a:rPr>
+              <a:t>Los conectores con herramientas externas están documentados, pero no se probaron en vivo con servicios reales</a:t>
+            </a:r>
+            <a:endParaRPr lang="en-US" sz="1500" dirty="0"/>
+          </a:p>
+          <a:p>
+            <a:pPr indent="0" marL="0">
+              <a:spcAft>
+                <a:spcPts val="1000"/>
+              </a:spcAft>
+              <a:buNone/>
+            </a:pPr>
+            <a:r>
+              <a:rPr lang="en-US" sz="1500" b="1" dirty="0">
+                <a:solidFill>
+                  <a:srgbClr val="B5651D"/>
+                </a:solidFill>
+              </a:rPr>
+              <a:t>▪  </a:t>
+            </a:r>
+            <a:pPr indent="0" marL="0">
+              <a:spcAft>
+                <a:spcPts val="1000"/>
+              </a:spcAft>
+              <a:buNone/>
+            </a:pPr>
+            <a:r>
+              <a:rPr lang="en-US" sz="1500" dirty="0">
+                <a:solidFill>
+                  <a:srgbClr val="272425"/>
+                </a:solidFill>
+              </a:rPr>
+              <a:t>El asistente puede interpretar distinto una frase: los comandos fijos son la vía segura</a:t>
+            </a:r>
+            <a:endParaRPr lang="en-US" sz="1500" dirty="0"/>
+          </a:p>
+          <a:p>
+            <a:pPr indent="0" marL="0">
+              <a:spcAft>
+                <a:spcPts val="1000"/>
+              </a:spcAft>
+              <a:buNone/>
+            </a:pPr>
+            <a:r>
+              <a:rPr lang="en-US" sz="1500" b="1" dirty="0">
+                <a:solidFill>
+                  <a:srgbClr val="B5651D"/>
+                </a:solidFill>
+              </a:rPr>
+              <a:t>▪  </a:t>
+            </a:r>
+            <a:pPr indent="0" marL="0">
+              <a:spcAft>
+                <a:spcPts val="1000"/>
+              </a:spcAft>
+              <a:buNone/>
+            </a:pPr>
+            <a:r>
+              <a:rPr lang="en-US" sz="1500" dirty="0">
+                <a:solidFill>
+                  <a:srgbClr val="272425"/>
+                </a:solidFill>
+              </a:rPr>
+              <a:t>No reemplaza el criterio profesional: las decisiones son siempre de una persona</a:t>
+            </a:r>
+            <a:endParaRPr lang="en-US" sz="1500" dirty="0"/>
+          </a:p>
+        </p:txBody>
+      </p:sp>
+      <p:sp>
+        <p:nvSpPr>
+          <p:cNvPr id="7" name="Shape 4"/>
+          <p:cNvSpPr/>
+          <p:nvPr/>
+        </p:nvSpPr>
+        <p:spPr>
+          <a:xfrm>
+            <a:off x="6190488" y="1298448"/>
+            <a:ext cx="5541264" cy="4114800"/>
+          </a:xfrm>
+          <a:prstGeom prst="roundRect">
+            <a:avLst>
+              <a:gd name="adj" fmla="val 1778"/>
+            </a:avLst>
+          </a:prstGeom>
+          <a:solidFill>
+            <a:srgbClr val="E9F1F8"/>
+          </a:solidFill>
+          <a:ln w="9525">
+            <a:solidFill>
+              <a:srgbClr val="E9F1F8"/>
+            </a:solidFill>
+            <a:prstDash val="solid"/>
+          </a:ln>
+        </p:spPr>
+      </p:sp>
+      <p:sp>
+        <p:nvSpPr>
+          <p:cNvPr id="8" name="Text 5"/>
+          <p:cNvSpPr txBox="1"/>
+          <p:nvPr/>
+        </p:nvSpPr>
+        <p:spPr>
+          <a:xfrm>
+            <a:off x="6391656" y="1463040"/>
+            <a:ext cx="5175504" cy="256032"/>
+          </a:xfrm>
+          <a:prstGeom prst="rect">
+            <a:avLst/>
+          </a:prstGeom>
+          <a:noFill/>
+          <a:ln/>
+        </p:spPr>
+        <p:txBody>
+          <a:bodyPr wrap="square" lIns="0" tIns="0" rIns="0" bIns="0" rtlCol="0" anchor="t"/>
+          <a:lstStyle/>
+          <a:p>
+            <a:pPr indent="0" marL="0">
+              <a:buNone/>
+            </a:pPr>
+            <a:r>
+              <a:rPr lang="en-US" sz="1100" b="1" spc="100" kern="0" dirty="0">
+                <a:solidFill>
+                  <a:srgbClr val="2B6A9A"/>
+                </a:solidFill>
+              </a:rPr>
+              <a:t>MATERIAL LISTO PARA APRENDER: CINCO CASOS DE PRÁCTICA</a:t>
+            </a:r>
+            <a:endParaRPr lang="en-US" sz="1100" dirty="0"/>
+          </a:p>
+        </p:txBody>
+      </p:sp>
+      <p:sp>
+        <p:nvSpPr>
+          <p:cNvPr id="9" name="Shape 6"/>
+          <p:cNvSpPr/>
+          <p:nvPr/>
+        </p:nvSpPr>
+        <p:spPr>
+          <a:xfrm>
+            <a:off x="6391656" y="1901952"/>
+            <a:ext cx="420624" cy="420624"/>
+          </a:xfrm>
+          <a:prstGeom prst="ellipse">
+            <a:avLst/>
+          </a:prstGeom>
+          <a:solidFill>
+            <a:srgbClr val="17324D"/>
+          </a:solidFill>
+          <a:ln w="12700">
+            <a:solidFill>
+              <a:srgbClr val="17324D"/>
+            </a:solidFill>
+            <a:prstDash val="solid"/>
+          </a:ln>
+        </p:spPr>
+      </p:sp>
+      <p:sp>
+        <p:nvSpPr>
+          <p:cNvPr id="10" name="Text 7"/>
+          <p:cNvSpPr txBox="1"/>
+          <p:nvPr/>
+        </p:nvSpPr>
+        <p:spPr>
+          <a:xfrm>
+            <a:off x="6391656" y="1901952"/>
+            <a:ext cx="420624" cy="420624"/>
+          </a:xfrm>
+          <a:prstGeom prst="rect">
+            <a:avLst/>
+          </a:prstGeom>
+          <a:noFill/>
+          <a:ln/>
+        </p:spPr>
+        <p:txBody>
+          <a:bodyPr wrap="square" lIns="0" tIns="0" rIns="0" bIns="0" rtlCol="0" anchor="ctr"/>
+          <a:lstStyle/>
+          <a:p>
+            <a:pPr algn="ctr" indent="0" marL="0">
+              <a:buNone/>
+            </a:pPr>
+            <a:r>
+              <a:rPr lang="en-US" sz="1400" b="1" dirty="0">
+                <a:solidFill>
+                  <a:srgbClr val="FFFFFF"/>
+                </a:solidFill>
+              </a:rPr>
+              <a:t>1</a:t>
+            </a:r>
+            <a:endParaRPr lang="en-US" sz="1400" dirty="0"/>
+          </a:p>
+        </p:txBody>
+      </p:sp>
+      <p:sp>
+        <p:nvSpPr>
+          <p:cNvPr id="11" name="Text 8"/>
+          <p:cNvSpPr txBox="1"/>
+          <p:nvPr/>
+        </p:nvSpPr>
+        <p:spPr>
+          <a:xfrm>
+            <a:off x="6958584" y="1865376"/>
+            <a:ext cx="4581144" cy="292608"/>
+          </a:xfrm>
+          <a:prstGeom prst="rect">
+            <a:avLst/>
+          </a:prstGeom>
+          <a:noFill/>
+          <a:ln/>
+        </p:spPr>
+        <p:txBody>
+          <a:bodyPr wrap="square" lIns="0" tIns="0" rIns="0" bIns="0" rtlCol="0" anchor="t"/>
+          <a:lstStyle/>
+          <a:p>
+            <a:pPr indent="0" marL="0">
+              <a:buNone/>
+            </a:pPr>
+            <a:r>
+              <a:rPr lang="en-US" sz="1500" b="1" dirty="0">
+                <a:solidFill>
+                  <a:srgbClr val="17324D"/>
+                </a:solidFill>
+              </a:rPr>
+              <a:t>Anticipar lo que puede salir mal</a:t>
+            </a:r>
+            <a:endParaRPr lang="en-US" sz="1500" dirty="0"/>
+          </a:p>
+        </p:txBody>
+      </p:sp>
+      <p:sp>
+        <p:nvSpPr>
+          <p:cNvPr id="12" name="Text 9"/>
+          <p:cNvSpPr txBox="1"/>
+          <p:nvPr/>
+        </p:nvSpPr>
+        <p:spPr>
+          <a:xfrm>
+            <a:off x="6958584" y="2157984"/>
+            <a:ext cx="4581144" cy="237744"/>
+          </a:xfrm>
+          <a:prstGeom prst="rect">
+            <a:avLst/>
+          </a:prstGeom>
+          <a:noFill/>
+          <a:ln/>
+        </p:spPr>
+        <p:txBody>
+          <a:bodyPr wrap="square" lIns="0" tIns="0" rIns="0" bIns="0" rtlCol="0" anchor="t"/>
+          <a:lstStyle/>
+          <a:p>
+            <a:pPr indent="0" marL="0">
+              <a:buNone/>
+            </a:pPr>
+            <a:r>
+              <a:rPr lang="en-US" sz="1200" i="1" dirty="0">
+                <a:solidFill>
+                  <a:srgbClr val="696969"/>
+                </a:solidFill>
+              </a:rPr>
+              <a:t>riesgos · caso E2E-1</a:t>
+            </a:r>
+            <a:endParaRPr lang="en-US" sz="1200" dirty="0"/>
+          </a:p>
+        </p:txBody>
+      </p:sp>
+      <p:sp>
+        <p:nvSpPr>
+          <p:cNvPr id="13" name="Shape 10"/>
+          <p:cNvSpPr/>
+          <p:nvPr/>
+        </p:nvSpPr>
+        <p:spPr>
+          <a:xfrm>
+            <a:off x="6391656" y="2587752"/>
+            <a:ext cx="420624" cy="420624"/>
+          </a:xfrm>
+          <a:prstGeom prst="ellipse">
+            <a:avLst/>
+          </a:prstGeom>
+          <a:solidFill>
+            <a:srgbClr val="17324D"/>
+          </a:solidFill>
+          <a:ln w="12700">
+            <a:solidFill>
+              <a:srgbClr val="17324D"/>
+            </a:solidFill>
+            <a:prstDash val="solid"/>
+          </a:ln>
+        </p:spPr>
+      </p:sp>
+      <p:sp>
+        <p:nvSpPr>
+          <p:cNvPr id="14" name="Text 11"/>
+          <p:cNvSpPr txBox="1"/>
+          <p:nvPr/>
+        </p:nvSpPr>
+        <p:spPr>
+          <a:xfrm>
+            <a:off x="6391656" y="2587752"/>
+            <a:ext cx="420624" cy="420624"/>
+          </a:xfrm>
+          <a:prstGeom prst="rect">
+            <a:avLst/>
+          </a:prstGeom>
+          <a:noFill/>
+          <a:ln/>
+        </p:spPr>
+        <p:txBody>
+          <a:bodyPr wrap="square" lIns="0" tIns="0" rIns="0" bIns="0" rtlCol="0" anchor="ctr"/>
+          <a:lstStyle/>
+          <a:p>
+            <a:pPr algn="ctr" indent="0" marL="0">
+              <a:buNone/>
+            </a:pPr>
+            <a:r>
+              <a:rPr lang="en-US" sz="1400" b="1" dirty="0">
+                <a:solidFill>
+                  <a:srgbClr val="FFFFFF"/>
+                </a:solidFill>
+              </a:rPr>
+              <a:t>2</a:t>
+            </a:r>
+            <a:endParaRPr lang="en-US" sz="1400" dirty="0"/>
+          </a:p>
+        </p:txBody>
+      </p:sp>
+      <p:sp>
+        <p:nvSpPr>
+          <p:cNvPr id="15" name="Text 12"/>
+          <p:cNvSpPr txBox="1"/>
+          <p:nvPr/>
+        </p:nvSpPr>
+        <p:spPr>
+          <a:xfrm>
+            <a:off x="6958584" y="2551176"/>
+            <a:ext cx="4581144" cy="292608"/>
+          </a:xfrm>
+          <a:prstGeom prst="rect">
+            <a:avLst/>
+          </a:prstGeom>
+          <a:noFill/>
+          <a:ln/>
+        </p:spPr>
+        <p:txBody>
+          <a:bodyPr wrap="square" lIns="0" tIns="0" rIns="0" bIns="0" rtlCol="0" anchor="t"/>
+          <a:lstStyle/>
+          <a:p>
+            <a:pPr indent="0" marL="0">
+              <a:buNone/>
+            </a:pPr>
+            <a:r>
+              <a:rPr lang="en-US" sz="1500" b="1" dirty="0">
+                <a:solidFill>
+                  <a:srgbClr val="17324D"/>
+                </a:solidFill>
+              </a:rPr>
+              <a:t>Cambiar el plan sin perder el control</a:t>
+            </a:r>
+            <a:endParaRPr lang="en-US" sz="1500" dirty="0"/>
+          </a:p>
+        </p:txBody>
+      </p:sp>
+      <p:sp>
+        <p:nvSpPr>
+          <p:cNvPr id="16" name="Text 13"/>
+          <p:cNvSpPr txBox="1"/>
+          <p:nvPr/>
+        </p:nvSpPr>
+        <p:spPr>
+          <a:xfrm>
+            <a:off x="6958584" y="2843784"/>
+            <a:ext cx="4581144" cy="237744"/>
+          </a:xfrm>
+          <a:prstGeom prst="rect">
+            <a:avLst/>
+          </a:prstGeom>
+          <a:noFill/>
+          <a:ln/>
+        </p:spPr>
+        <p:txBody>
+          <a:bodyPr wrap="square" lIns="0" tIns="0" rIns="0" bIns="0" rtlCol="0" anchor="t"/>
+          <a:lstStyle/>
+          <a:p>
+            <a:pPr indent="0" marL="0">
+              <a:buNone/>
+            </a:pPr>
+            <a:r>
+              <a:rPr lang="en-US" sz="1200" i="1" dirty="0">
+                <a:solidFill>
+                  <a:srgbClr val="696969"/>
+                </a:solidFill>
+              </a:rPr>
+              <a:t>alcance y cambios · caso E2E-2</a:t>
+            </a:r>
+            <a:endParaRPr lang="en-US" sz="1200" dirty="0"/>
+          </a:p>
+        </p:txBody>
+      </p:sp>
+      <p:sp>
+        <p:nvSpPr>
+          <p:cNvPr id="17" name="Shape 14"/>
+          <p:cNvSpPr/>
+          <p:nvPr/>
+        </p:nvSpPr>
+        <p:spPr>
+          <a:xfrm>
+            <a:off x="6391656" y="3273552"/>
+            <a:ext cx="420624" cy="420624"/>
+          </a:xfrm>
+          <a:prstGeom prst="ellipse">
+            <a:avLst/>
+          </a:prstGeom>
+          <a:solidFill>
+            <a:srgbClr val="17324D"/>
+          </a:solidFill>
+          <a:ln w="12700">
+            <a:solidFill>
+              <a:srgbClr val="17324D"/>
+            </a:solidFill>
+            <a:prstDash val="solid"/>
+          </a:ln>
+        </p:spPr>
+      </p:sp>
+      <p:sp>
+        <p:nvSpPr>
+          <p:cNvPr id="18" name="Text 15"/>
+          <p:cNvSpPr txBox="1"/>
+          <p:nvPr/>
+        </p:nvSpPr>
+        <p:spPr>
+          <a:xfrm>
+            <a:off x="6391656" y="3273552"/>
+            <a:ext cx="420624" cy="420624"/>
+          </a:xfrm>
+          <a:prstGeom prst="rect">
+            <a:avLst/>
+          </a:prstGeom>
+          <a:noFill/>
+          <a:ln/>
+        </p:spPr>
+        <p:txBody>
+          <a:bodyPr wrap="square" lIns="0" tIns="0" rIns="0" bIns="0" rtlCol="0" anchor="ctr"/>
+          <a:lstStyle/>
+          <a:p>
+            <a:pPr algn="ctr" indent="0" marL="0">
+              <a:buNone/>
+            </a:pPr>
+            <a:r>
+              <a:rPr lang="en-US" sz="1400" b="1" dirty="0">
+                <a:solidFill>
+                  <a:srgbClr val="FFFFFF"/>
+                </a:solidFill>
+              </a:rPr>
+              <a:t>3</a:t>
+            </a:r>
+            <a:endParaRPr lang="en-US" sz="1400" dirty="0"/>
+          </a:p>
+        </p:txBody>
+      </p:sp>
+      <p:sp>
+        <p:nvSpPr>
+          <p:cNvPr id="19" name="Text 16"/>
+          <p:cNvSpPr txBox="1"/>
+          <p:nvPr/>
+        </p:nvSpPr>
+        <p:spPr>
+          <a:xfrm>
+            <a:off x="6958584" y="3236976"/>
+            <a:ext cx="4581144" cy="292608"/>
+          </a:xfrm>
+          <a:prstGeom prst="rect">
+            <a:avLst/>
+          </a:prstGeom>
+          <a:noFill/>
+          <a:ln/>
+        </p:spPr>
+        <p:txBody>
+          <a:bodyPr wrap="square" lIns="0" tIns="0" rIns="0" bIns="0" rtlCol="0" anchor="t"/>
+          <a:lstStyle/>
+          <a:p>
+            <a:pPr indent="0" marL="0">
+              <a:buNone/>
+            </a:pPr>
+            <a:r>
+              <a:rPr lang="en-US" sz="1500" b="1" dirty="0">
+                <a:solidFill>
+                  <a:srgbClr val="17324D"/>
+                </a:solidFill>
+              </a:rPr>
+              <a:t>Informar a cada persona lo que necesita</a:t>
+            </a:r>
+            <a:endParaRPr lang="en-US" sz="1500" dirty="0"/>
+          </a:p>
+        </p:txBody>
+      </p:sp>
+      <p:sp>
+        <p:nvSpPr>
+          <p:cNvPr id="20" name="Text 17"/>
+          <p:cNvSpPr txBox="1"/>
+          <p:nvPr/>
+        </p:nvSpPr>
+        <p:spPr>
+          <a:xfrm>
+            <a:off x="6958584" y="3529584"/>
+            <a:ext cx="4581144" cy="237744"/>
+          </a:xfrm>
+          <a:prstGeom prst="rect">
+            <a:avLst/>
+          </a:prstGeom>
+          <a:noFill/>
+          <a:ln/>
+        </p:spPr>
+        <p:txBody>
+          <a:bodyPr wrap="square" lIns="0" tIns="0" rIns="0" bIns="0" rtlCol="0" anchor="t"/>
+          <a:lstStyle/>
+          <a:p>
+            <a:pPr indent="0" marL="0">
+              <a:buNone/>
+            </a:pPr>
+            <a:r>
+              <a:rPr lang="en-US" sz="1200" i="1" dirty="0">
+                <a:solidFill>
+                  <a:srgbClr val="696969"/>
+                </a:solidFill>
+              </a:rPr>
+              <a:t>interesados y avance · caso E2E-3</a:t>
+            </a:r>
+            <a:endParaRPr lang="en-US" sz="1200" dirty="0"/>
+          </a:p>
+        </p:txBody>
+      </p:sp>
+      <p:sp>
+        <p:nvSpPr>
+          <p:cNvPr id="21" name="Shape 18"/>
+          <p:cNvSpPr/>
+          <p:nvPr/>
+        </p:nvSpPr>
+        <p:spPr>
+          <a:xfrm>
+            <a:off x="6391656" y="3959352"/>
+            <a:ext cx="420624" cy="420624"/>
+          </a:xfrm>
+          <a:prstGeom prst="ellipse">
+            <a:avLst/>
+          </a:prstGeom>
+          <a:solidFill>
+            <a:srgbClr val="17324D"/>
+          </a:solidFill>
+          <a:ln w="12700">
+            <a:solidFill>
+              <a:srgbClr val="17324D"/>
+            </a:solidFill>
+            <a:prstDash val="solid"/>
+          </a:ln>
+        </p:spPr>
+      </p:sp>
+      <p:sp>
+        <p:nvSpPr>
+          <p:cNvPr id="22" name="Text 19"/>
+          <p:cNvSpPr txBox="1"/>
+          <p:nvPr/>
+        </p:nvSpPr>
+        <p:spPr>
+          <a:xfrm>
+            <a:off x="6391656" y="3959352"/>
+            <a:ext cx="420624" cy="420624"/>
+          </a:xfrm>
+          <a:prstGeom prst="rect">
+            <a:avLst/>
+          </a:prstGeom>
+          <a:noFill/>
+          <a:ln/>
+        </p:spPr>
+        <p:txBody>
+          <a:bodyPr wrap="square" lIns="0" tIns="0" rIns="0" bIns="0" rtlCol="0" anchor="ctr"/>
+          <a:lstStyle/>
+          <a:p>
+            <a:pPr algn="ctr" indent="0" marL="0">
+              <a:buNone/>
+            </a:pPr>
+            <a:r>
+              <a:rPr lang="en-US" sz="1400" b="1" dirty="0">
+                <a:solidFill>
+                  <a:srgbClr val="FFFFFF"/>
+                </a:solidFill>
+              </a:rPr>
+              <a:t>4</a:t>
+            </a:r>
+            <a:endParaRPr lang="en-US" sz="1400" dirty="0"/>
+          </a:p>
+        </p:txBody>
+      </p:sp>
+      <p:sp>
+        <p:nvSpPr>
+          <p:cNvPr id="23" name="Text 20"/>
+          <p:cNvSpPr txBox="1"/>
+          <p:nvPr/>
+        </p:nvSpPr>
+        <p:spPr>
+          <a:xfrm>
+            <a:off x="6958584" y="3922776"/>
+            <a:ext cx="4581144" cy="292608"/>
+          </a:xfrm>
+          <a:prstGeom prst="rect">
+            <a:avLst/>
+          </a:prstGeom>
+          <a:noFill/>
+          <a:ln/>
+        </p:spPr>
+        <p:txBody>
+          <a:bodyPr wrap="square" lIns="0" tIns="0" rIns="0" bIns="0" rtlCol="0" anchor="t"/>
+          <a:lstStyle/>
+          <a:p>
+            <a:pPr indent="0" marL="0">
+              <a:buNone/>
+            </a:pPr>
+            <a:r>
+              <a:rPr lang="en-US" sz="1500" b="1" dirty="0">
+                <a:solidFill>
+                  <a:srgbClr val="17324D"/>
+                </a:solidFill>
+              </a:rPr>
+              <a:t>Construir un producto de software con control</a:t>
+            </a:r>
+            <a:endParaRPr lang="en-US" sz="1500" dirty="0"/>
+          </a:p>
+        </p:txBody>
+      </p:sp>
+      <p:sp>
+        <p:nvSpPr>
+          <p:cNvPr id="24" name="Text 21"/>
+          <p:cNvSpPr txBox="1"/>
+          <p:nvPr/>
+        </p:nvSpPr>
+        <p:spPr>
+          <a:xfrm>
+            <a:off x="6958584" y="4215384"/>
+            <a:ext cx="4581144" cy="237744"/>
+          </a:xfrm>
+          <a:prstGeom prst="rect">
+            <a:avLst/>
+          </a:prstGeom>
+          <a:noFill/>
+          <a:ln/>
+        </p:spPr>
+        <p:txBody>
+          <a:bodyPr wrap="square" lIns="0" tIns="0" rIns="0" bIns="0" rtlCol="0" anchor="t"/>
+          <a:lstStyle/>
+          <a:p>
+            <a:pPr indent="0" marL="0">
+              <a:buNone/>
+            </a:pPr>
+            <a:r>
+              <a:rPr lang="en-US" sz="1200" i="1" dirty="0">
+                <a:solidFill>
+                  <a:srgbClr val="696969"/>
+                </a:solidFill>
+              </a:rPr>
+              <a:t>producto con IA · caso E2E-4</a:t>
+            </a:r>
+            <a:endParaRPr lang="en-US" sz="1200" dirty="0"/>
+          </a:p>
+        </p:txBody>
+      </p:sp>
+      <p:sp>
+        <p:nvSpPr>
+          <p:cNvPr id="25" name="Shape 22"/>
+          <p:cNvSpPr/>
+          <p:nvPr/>
+        </p:nvSpPr>
+        <p:spPr>
+          <a:xfrm>
+            <a:off x="6391656" y="4645152"/>
+            <a:ext cx="420624" cy="420624"/>
+          </a:xfrm>
+          <a:prstGeom prst="ellipse">
+            <a:avLst/>
+          </a:prstGeom>
+          <a:solidFill>
+            <a:srgbClr val="17324D"/>
+          </a:solidFill>
+          <a:ln w="12700">
+            <a:solidFill>
+              <a:srgbClr val="17324D"/>
+            </a:solidFill>
+            <a:prstDash val="solid"/>
+          </a:ln>
+        </p:spPr>
+      </p:sp>
+      <p:sp>
+        <p:nvSpPr>
+          <p:cNvPr id="26" name="Text 23"/>
+          <p:cNvSpPr txBox="1"/>
+          <p:nvPr/>
+        </p:nvSpPr>
+        <p:spPr>
+          <a:xfrm>
+            <a:off x="6391656" y="4645152"/>
+            <a:ext cx="420624" cy="420624"/>
+          </a:xfrm>
+          <a:prstGeom prst="rect">
+            <a:avLst/>
+          </a:prstGeom>
+          <a:noFill/>
+          <a:ln/>
+        </p:spPr>
+        <p:txBody>
+          <a:bodyPr wrap="square" lIns="0" tIns="0" rIns="0" bIns="0" rtlCol="0" anchor="ctr"/>
+          <a:lstStyle/>
+          <a:p>
+            <a:pPr algn="ctr" indent="0" marL="0">
+              <a:buNone/>
+            </a:pPr>
+            <a:r>
+              <a:rPr lang="en-US" sz="1400" b="1" dirty="0">
+                <a:solidFill>
+                  <a:srgbClr val="FFFFFF"/>
+                </a:solidFill>
+              </a:rPr>
+              <a:t>5</a:t>
+            </a:r>
+            <a:endParaRPr lang="en-US" sz="1400" dirty="0"/>
+          </a:p>
+        </p:txBody>
+      </p:sp>
+      <p:sp>
+        <p:nvSpPr>
+          <p:cNvPr id="27" name="Text 24"/>
+          <p:cNvSpPr txBox="1"/>
+          <p:nvPr/>
+        </p:nvSpPr>
+        <p:spPr>
+          <a:xfrm>
+            <a:off x="6958584" y="4608576"/>
+            <a:ext cx="4581144" cy="292608"/>
+          </a:xfrm>
+          <a:prstGeom prst="rect">
+            <a:avLst/>
+          </a:prstGeom>
+          <a:noFill/>
+          <a:ln/>
+        </p:spPr>
+        <p:txBody>
+          <a:bodyPr wrap="square" lIns="0" tIns="0" rIns="0" bIns="0" rtlCol="0" anchor="t"/>
+          <a:lstStyle/>
+          <a:p>
+            <a:pPr indent="0" marL="0">
+              <a:buNone/>
+            </a:pPr>
+            <a:r>
+              <a:rPr lang="en-US" sz="1500" b="1" dirty="0">
+                <a:solidFill>
+                  <a:srgbClr val="17324D"/>
+                </a:solidFill>
+              </a:rPr>
+              <a:t>Decidir si una idea vale la pena antes de invertir</a:t>
+            </a:r>
+            <a:endParaRPr lang="en-US" sz="1500" dirty="0"/>
+          </a:p>
+        </p:txBody>
+      </p:sp>
+      <p:sp>
+        <p:nvSpPr>
+          <p:cNvPr id="28" name="Text 25"/>
+          <p:cNvSpPr txBox="1"/>
+          <p:nvPr/>
+        </p:nvSpPr>
+        <p:spPr>
+          <a:xfrm>
+            <a:off x="6958584" y="4901184"/>
+            <a:ext cx="4581144" cy="237744"/>
+          </a:xfrm>
+          <a:prstGeom prst="rect">
+            <a:avLst/>
+          </a:prstGeom>
+          <a:noFill/>
+          <a:ln/>
+        </p:spPr>
+        <p:txBody>
+          <a:bodyPr wrap="square" lIns="0" tIns="0" rIns="0" bIns="0" rtlCol="0" anchor="t"/>
+          <a:lstStyle/>
+          <a:p>
+            <a:pPr indent="0" marL="0">
+              <a:buNone/>
+            </a:pPr>
+            <a:r>
+              <a:rPr lang="en-US" sz="1200" i="1" dirty="0">
+                <a:solidFill>
+                  <a:srgbClr val="696969"/>
+                </a:solidFill>
+              </a:rPr>
+              <a:t>de la idea al proyecto · caso E2E-5</a:t>
+            </a:r>
+            <a:endParaRPr lang="en-US" sz="1200" dirty="0"/>
+          </a:p>
+        </p:txBody>
+      </p:sp>
+      <p:sp>
+        <p:nvSpPr>
+          <p:cNvPr id="29" name="Shape 26"/>
+          <p:cNvSpPr/>
+          <p:nvPr/>
+        </p:nvSpPr>
+        <p:spPr>
+          <a:xfrm>
+            <a:off x="457200" y="5559552"/>
+            <a:ext cx="11274552" cy="676656"/>
+          </a:xfrm>
+          <a:prstGeom prst="roundRect">
+            <a:avLst>
+              <a:gd name="adj" fmla="val 10811"/>
+            </a:avLst>
+          </a:prstGeom>
+          <a:solidFill>
+            <a:srgbClr val="FBF1E6"/>
+          </a:solidFill>
+          <a:ln w="9525">
+            <a:solidFill>
+              <a:srgbClr val="FBF1E6"/>
+            </a:solidFill>
+            <a:prstDash val="solid"/>
+          </a:ln>
+        </p:spPr>
+      </p:sp>
+      <p:sp>
+        <p:nvSpPr>
+          <p:cNvPr id="30" name="Text 27"/>
+          <p:cNvSpPr txBox="1"/>
+          <p:nvPr/>
+        </p:nvSpPr>
+        <p:spPr>
+          <a:xfrm>
+            <a:off x="685800" y="5559552"/>
+            <a:ext cx="10881360" cy="676656"/>
+          </a:xfrm>
+          <a:prstGeom prst="rect">
+            <a:avLst/>
+          </a:prstGeom>
+          <a:noFill/>
+          <a:ln/>
+        </p:spPr>
+        <p:txBody>
+          <a:bodyPr wrap="square" lIns="0" tIns="0" rIns="0" bIns="0" rtlCol="0" anchor="ctr"/>
+          <a:lstStyle/>
+          <a:p>
+            <a:pPr indent="0" marL="0">
+              <a:buNone/>
+            </a:pPr>
+            <a:r>
+              <a:rPr lang="en-US" sz="1600" b="1" dirty="0">
+                <a:solidFill>
+                  <a:srgbClr val="B5651D"/>
+                </a:solidFill>
+              </a:rPr>
+              <a:t>Siguiente paso para IEEE: un piloto de formación de 4 a 6 sesiones (detalle en la presentación de resumen)</a:t>
+            </a:r>
+            <a:endParaRPr lang="en-US" sz="1600" dirty="0"/>
+          </a:p>
+        </p:txBody>
+      </p:sp>
+      <p:sp>
+        <p:nvSpPr>
+          <p:cNvPr id="25" name="Slide Number Placeholder 0"/>
+          <p:cNvSpPr>
+            <a:spLocks noGrp="1"/>
+          </p:cNvSpPr>
+          <p:nvPr>
+            <p:ph type="sldNum" sz="quarter" idx="4294967295"/>
+          </p:nvPr>
+        </p:nvSpPr>
+        <p:spPr>
+          <a:xfrm>
+            <a:off x="11091672" y="6419088"/>
+            <a:ext cx="640080" cy="274320"/>
+          </a:xfrm>
+          <a:prstGeom prst="rect">
+            <a:avLst/>
+          </a:prstGeom>
+          <a:extLst>
+            <a:ext uri="{C572A759-6A51-4108-AA02-DFA0A04FC94B}">
+              <ma14:wrappingTextBoxFlag xmlns:ma14="http://schemas.microsoft.com/office/mac/drawingml/2011/main" val="0"/>
+            </a:ext>
+          </a:extLst>
+        </p:spPr>
+        <p:txBody>
+          <a:bodyPr/>
+          <a:lstStyle>
+            <a:lvl1pPr>
+              <a:defRPr sz="900">
+                <a:solidFill>
+                  <a:srgbClr val="696969"/>
+                </a:solidFill>
+              </a:defRPr>
+            </a:lvl1pPr>
+          </a:lstStyle>
+          <a:p>
+            <a:pPr algn="r"/>
+            <a:fld id="{F7021451-1387-4CA6-816F-3879F97B5CBC}" type="slidenum">
+              <a:rPr b="0" lang="en-US"/>
+              <a:t>10</a:t>
+            </a:fld>
+            <a:endParaRPr lang="en-US"/>
           </a:p>
         </p:txBody>
       </p:sp>
@@ -8414,7 +9611,7 @@
                   <a:srgbClr val="FFFFFF"/>
                 </a:solidFill>
               </a:rPr>
-              <a:t>Ventajas: decisiones trazables, datos que cuadran y menos trabajo administrativo</a:t>
+              <a:t>Decidir con la evidencia a la vista y encontrarla después con la fuente citada</a:t>
             </a:r>
             <a:endParaRPr lang="en-US" sz="1900" dirty="0"/>
           </a:p>
@@ -8428,12 +9625,133 @@
         </p:nvSpPr>
         <p:spPr>
           <a:xfrm>
-            <a:off x="457200" y="1298448"/>
-            <a:ext cx="5541264" cy="1572768"/>
+            <a:off x="420624" y="1335024"/>
+            <a:ext cx="7022592" cy="3982212"/>
+          </a:xfrm>
+          <a:prstGeom prst="rect">
+            <a:avLst/>
+          </a:prstGeom>
+          <a:solidFill>
+            <a:srgbClr val="FFFFFF"/>
+          </a:solidFill>
+          <a:ln w="9525">
+            <a:solidFill>
+              <a:srgbClr val="D5DCE3"/>
+            </a:solidFill>
+            <a:prstDash val="solid"/>
+          </a:ln>
+        </p:spPr>
+      </p:sp>
+      <p:pic>
+        <p:nvPicPr>
+          <p:cNvPr id="5" name="Image 0" descr="g1-kb-busqueda.png">    </p:cNvPr>
+          <p:cNvPicPr>
+            <a:picLocks noChangeAspect="1"/>
+          </p:cNvPicPr>
+          <p:nvPr/>
+        </p:nvPicPr>
+        <p:blipFill>
+          <a:blip r:embed="rId1"/>
+          <a:stretch>
+            <a:fillRect/>
+          </a:stretch>
+        </p:blipFill>
+        <p:spPr>
+          <a:xfrm>
+            <a:off x="457200" y="1371600"/>
+            <a:ext cx="6949440" cy="3909060"/>
+          </a:xfrm>
+          <a:prstGeom prst="rect">
+            <a:avLst/>
+          </a:prstGeom>
+        </p:spPr>
+      </p:pic>
+      <p:sp>
+        <p:nvSpPr>
+          <p:cNvPr id="6" name="Text 2"/>
+          <p:cNvSpPr txBox="1"/>
+          <p:nvPr/>
+        </p:nvSpPr>
+        <p:spPr>
+          <a:xfrm>
+            <a:off x="457200" y="5408676"/>
+            <a:ext cx="6949440" cy="603504"/>
+          </a:xfrm>
+          <a:prstGeom prst="rect">
+            <a:avLst/>
+          </a:prstGeom>
+          <a:noFill/>
+          <a:ln/>
+        </p:spPr>
+        <p:txBody>
+          <a:bodyPr wrap="square" lIns="0" tIns="0" rIns="0" bIns="0" rtlCol="0" anchor="t"/>
+          <a:lstStyle/>
+          <a:p>
+            <a:pPr indent="0" marL="0">
+              <a:buNone/>
+            </a:pPr>
+            <a:r>
+              <a:rPr lang="en-US" sz="1300" i="1" dirty="0">
+                <a:solidFill>
+                  <a:srgbClr val="696969"/>
+                </a:solidFill>
+              </a:rPr>
+              <a:t>Caso de práctica: a la pregunta «¿por qué no se aprobó la compra de licencias de diseño?», el buscador trae primero el cambio rechazado, con el motivo y la cita</a:t>
+            </a:r>
+            <a:endParaRPr lang="en-US" sz="1300" dirty="0"/>
+          </a:p>
+        </p:txBody>
+      </p:sp>
+      <p:sp>
+        <p:nvSpPr>
+          <p:cNvPr id="7" name="Text 3"/>
+          <p:cNvSpPr txBox="1"/>
+          <p:nvPr/>
+        </p:nvSpPr>
+        <p:spPr>
+          <a:xfrm>
+            <a:off x="7726680" y="1298448"/>
+            <a:ext cx="4005072" cy="256032"/>
+          </a:xfrm>
+          <a:prstGeom prst="rect">
+            <a:avLst/>
+          </a:prstGeom>
+          <a:noFill/>
+          <a:ln/>
+        </p:spPr>
+        <p:txBody>
+          <a:bodyPr wrap="square" lIns="0" tIns="0" rIns="0" bIns="0" rtlCol="0" anchor="t"/>
+          <a:lstStyle/>
+          <a:p>
+            <a:pPr indent="0" marL="0">
+              <a:buNone/>
+            </a:pPr>
+            <a:r>
+              <a:rPr lang="en-US" sz="1100" b="1" spc="100" kern="0" dirty="0">
+                <a:solidFill>
+                  <a:srgbClr val="2B6A9A"/>
+                </a:solidFill>
+              </a:rPr>
+              <a:t>DECIDIR Y BUSCAR CON EVIDENCIA</a:t>
+            </a:r>
+            <a:endParaRPr lang="en-US" sz="1100" dirty="0"/>
+          </a:p>
+        </p:txBody>
+      </p:sp>
+      <p:sp>
+        <p:nvSpPr>
+          <p:cNvPr id="8" name="Shape 4"/>
+          <p:cNvSpPr/>
+          <p:nvPr/>
+        </p:nvSpPr>
+        <p:spPr>
+          <a:xfrm>
+            <a:off x="7726680" y="1627632"/>
+            <a:ext cx="4005072" cy="1035558"/>
           </a:xfrm>
           <a:prstGeom prst="roundRect">
             <a:avLst>
-              <a:gd name="adj" fmla="val 4651"/>
+              <a:gd name="adj" fmla="val 7064"/>
             </a:avLst>
           </a:prstGeom>
           <a:solidFill>
@@ -8449,14 +9767,14 @@
       </p:sp>
       <p:sp>
         <p:nvSpPr>
-          <p:cNvPr id="5" name="Shape 2"/>
+          <p:cNvPr id="9" name="Shape 5"/>
           <p:cNvSpPr/>
           <p:nvPr/>
         </p:nvSpPr>
         <p:spPr>
           <a:xfrm>
-            <a:off x="658368" y="1481328"/>
-            <a:ext cx="457200" cy="457200"/>
+            <a:off x="7891272" y="1944243"/>
+            <a:ext cx="402336" cy="402336"/>
           </a:xfrm>
           <a:prstGeom prst="ellipse">
             <a:avLst/>
@@ -8474,14 +9792,14 @@
       </p:sp>
       <p:sp>
         <p:nvSpPr>
-          <p:cNvPr id="6" name="Text 3"/>
-          <p:cNvSpPr txBox="1"/>
-          <p:nvPr/>
-        </p:nvSpPr>
-        <p:spPr>
-          <a:xfrm>
-            <a:off x="658368" y="1481328"/>
-            <a:ext cx="457200" cy="457200"/>
+          <p:cNvPr id="10" name="Text 6"/>
+          <p:cNvSpPr txBox="1"/>
+          <p:nvPr/>
+        </p:nvSpPr>
+        <p:spPr>
+          <a:xfrm>
+            <a:off x="7891272" y="1944243"/>
+            <a:ext cx="402336" cy="402336"/>
           </a:xfrm>
           <a:prstGeom prst="rect">
             <a:avLst/>
@@ -8497,103 +9815,67 @@
               <a:buNone/>
             </a:pPr>
             <a:r>
-              <a:rPr lang="en-US" sz="1600" b="1" dirty="0">
+              <a:rPr lang="en-US" sz="1400" b="1" dirty="0">
                 <a:solidFill>
                   <a:srgbClr val="FFFFFF"/>
                 </a:solidFill>
               </a:rPr>
               <a:t>1</a:t>
             </a:r>
+            <a:endParaRPr lang="en-US" sz="1400" dirty="0"/>
+          </a:p>
+        </p:txBody>
+      </p:sp>
+      <p:sp>
+        <p:nvSpPr>
+          <p:cNvPr id="11" name="Text 7"/>
+          <p:cNvSpPr txBox="1"/>
+          <p:nvPr/>
+        </p:nvSpPr>
+        <p:spPr>
+          <a:xfrm>
+            <a:off x="8458200" y="1719072"/>
+            <a:ext cx="3108960" cy="852678"/>
+          </a:xfrm>
+          <a:prstGeom prst="rect">
+            <a:avLst/>
+          </a:prstGeom>
+          <a:noFill/>
+          <a:ln/>
+        </p:spPr>
+        <p:txBody>
+          <a:bodyPr wrap="square" lIns="0" tIns="0" rIns="0" bIns="0" rtlCol="0" anchor="ctr"/>
+          <a:lstStyle/>
+          <a:p>
+            <a:pPr indent="0" marL="0">
+              <a:buNone/>
+            </a:pPr>
+            <a:r>
+              <a:rPr lang="en-US" sz="1600" dirty="0">
+                <a:solidFill>
+                  <a:srgbClr val="17324D"/>
+                </a:solidFill>
+              </a:rPr>
+              <a:t>Antes de elegir, el sistema reúne la evidencia que aplica, cada dato con su fuente</a:t>
+            </a:r>
             <a:endParaRPr lang="en-US" sz="1600" dirty="0"/>
           </a:p>
         </p:txBody>
       </p:sp>
       <p:sp>
         <p:nvSpPr>
-          <p:cNvPr id="7" name="Text 4"/>
-          <p:cNvSpPr txBox="1"/>
-          <p:nvPr/>
-        </p:nvSpPr>
-        <p:spPr>
-          <a:xfrm>
-            <a:off x="1280160" y="1481328"/>
-            <a:ext cx="4535424" cy="457200"/>
-          </a:xfrm>
-          <a:prstGeom prst="rect">
-            <a:avLst/>
-          </a:prstGeom>
-          <a:noFill/>
-          <a:ln/>
-        </p:spPr>
-        <p:txBody>
-          <a:bodyPr wrap="square" lIns="0" tIns="0" rIns="0" bIns="0" rtlCol="0" anchor="ctr"/>
-          <a:lstStyle/>
-          <a:p>
-            <a:pPr indent="0" marL="0">
-              <a:buNone/>
-            </a:pPr>
-            <a:r>
-              <a:rPr lang="en-US" sz="1800" b="1" dirty="0">
-                <a:solidFill>
-                  <a:srgbClr val="17324D"/>
-                </a:solidFill>
-              </a:rPr>
-              <a:t>Quien gestiona proyectos</a:t>
-            </a:r>
-            <a:endParaRPr lang="en-US" sz="1800" dirty="0"/>
-          </a:p>
-        </p:txBody>
-      </p:sp>
-      <p:sp>
-        <p:nvSpPr>
-          <p:cNvPr id="8" name="Text 5"/>
-          <p:cNvSpPr txBox="1"/>
-          <p:nvPr/>
-        </p:nvSpPr>
-        <p:spPr>
-          <a:xfrm>
-            <a:off x="1280160" y="2011680"/>
-            <a:ext cx="4535424" cy="749808"/>
-          </a:xfrm>
-          <a:prstGeom prst="rect">
-            <a:avLst/>
-          </a:prstGeom>
-          <a:noFill/>
-          <a:ln/>
-        </p:spPr>
-        <p:txBody>
-          <a:bodyPr wrap="square" lIns="0" tIns="0" rIns="0" bIns="0" rtlCol="0" anchor="t"/>
-          <a:lstStyle/>
-          <a:p>
-            <a:pPr indent="0" marL="0">
-              <a:buNone/>
-            </a:pPr>
-            <a:r>
-              <a:rPr lang="en-US" sz="1500" dirty="0">
-                <a:solidFill>
-                  <a:srgbClr val="272425"/>
-                </a:solidFill>
-              </a:rPr>
-              <a:t>Planes, registros e informes preparados con método; menos tiempo armando documentos</a:t>
-            </a:r>
-            <a:endParaRPr lang="en-US" sz="1500" dirty="0"/>
-          </a:p>
-        </p:txBody>
-      </p:sp>
-      <p:sp>
-        <p:nvSpPr>
-          <p:cNvPr id="9" name="Shape 6"/>
+          <p:cNvPr id="12" name="Shape 8"/>
           <p:cNvSpPr/>
           <p:nvPr/>
         </p:nvSpPr>
         <p:spPr>
           <a:xfrm>
-            <a:off x="6190488" y="1298448"/>
-            <a:ext cx="5541264" cy="1572768"/>
+            <a:off x="7726680" y="2791206"/>
+            <a:ext cx="4005072" cy="1035558"/>
           </a:xfrm>
           <a:prstGeom prst="roundRect">
             <a:avLst>
-              <a:gd name="adj" fmla="val 4651"/>
+              <a:gd name="adj" fmla="val 7064"/>
             </a:avLst>
           </a:prstGeom>
           <a:solidFill>
@@ -8609,14 +9891,14 @@
       </p:sp>
       <p:sp>
         <p:nvSpPr>
-          <p:cNvPr id="10" name="Shape 7"/>
+          <p:cNvPr id="13" name="Shape 9"/>
           <p:cNvSpPr/>
           <p:nvPr/>
         </p:nvSpPr>
         <p:spPr>
           <a:xfrm>
-            <a:off x="6391656" y="1481328"/>
-            <a:ext cx="457200" cy="457200"/>
+            <a:off x="7891272" y="3107817"/>
+            <a:ext cx="402336" cy="402336"/>
           </a:xfrm>
           <a:prstGeom prst="ellipse">
             <a:avLst/>
@@ -8634,14 +9916,14 @@
       </p:sp>
       <p:sp>
         <p:nvSpPr>
-          <p:cNvPr id="11" name="Text 8"/>
-          <p:cNvSpPr txBox="1"/>
-          <p:nvPr/>
-        </p:nvSpPr>
-        <p:spPr>
-          <a:xfrm>
-            <a:off x="6391656" y="1481328"/>
-            <a:ext cx="457200" cy="457200"/>
+          <p:cNvPr id="14" name="Text 10"/>
+          <p:cNvSpPr txBox="1"/>
+          <p:nvPr/>
+        </p:nvSpPr>
+        <p:spPr>
+          <a:xfrm>
+            <a:off x="7891272" y="3107817"/>
+            <a:ext cx="402336" cy="402336"/>
           </a:xfrm>
           <a:prstGeom prst="rect">
             <a:avLst/>
@@ -8657,27 +9939,27 @@
               <a:buNone/>
             </a:pPr>
             <a:r>
-              <a:rPr lang="en-US" sz="1600" b="1" dirty="0">
+              <a:rPr lang="en-US" sz="1400" b="1" dirty="0">
                 <a:solidFill>
                   <a:srgbClr val="FFFFFF"/>
                 </a:solidFill>
               </a:rPr>
               <a:t>2</a:t>
             </a:r>
-            <a:endParaRPr lang="en-US" sz="1600" dirty="0"/>
-          </a:p>
-        </p:txBody>
-      </p:sp>
-      <p:sp>
-        <p:nvSpPr>
-          <p:cNvPr id="12" name="Text 9"/>
-          <p:cNvSpPr txBox="1"/>
-          <p:nvPr/>
-        </p:nvSpPr>
-        <p:spPr>
-          <a:xfrm>
-            <a:off x="7013448" y="1481328"/>
-            <a:ext cx="4535424" cy="457200"/>
+            <a:endParaRPr lang="en-US" sz="1400" dirty="0"/>
+          </a:p>
+        </p:txBody>
+      </p:sp>
+      <p:sp>
+        <p:nvSpPr>
+          <p:cNvPr id="15" name="Text 11"/>
+          <p:cNvSpPr txBox="1"/>
+          <p:nvPr/>
+        </p:nvSpPr>
+        <p:spPr>
+          <a:xfrm>
+            <a:off x="8458200" y="2882646"/>
+            <a:ext cx="3108960" cy="852678"/>
           </a:xfrm>
           <a:prstGeom prst="rect">
             <a:avLst/>
@@ -8693,48 +9975,12 @@
               <a:buNone/>
             </a:pPr>
             <a:r>
-              <a:rPr lang="en-US" sz="1800" b="1" dirty="0">
+              <a:rPr lang="en-US" sz="1500" dirty="0">
                 <a:solidFill>
                   <a:srgbClr val="17324D"/>
                 </a:solidFill>
               </a:rPr>
-              <a:t>Quien dirige o patrocina</a:t>
-            </a:r>
-            <a:endParaRPr lang="en-US" sz="1800" dirty="0"/>
-          </a:p>
-        </p:txBody>
-      </p:sp>
-      <p:sp>
-        <p:nvSpPr>
-          <p:cNvPr id="13" name="Text 10"/>
-          <p:cNvSpPr txBox="1"/>
-          <p:nvPr/>
-        </p:nvSpPr>
-        <p:spPr>
-          <a:xfrm>
-            <a:off x="7013448" y="2011680"/>
-            <a:ext cx="4535424" cy="749808"/>
-          </a:xfrm>
-          <a:prstGeom prst="rect">
-            <a:avLst/>
-          </a:prstGeom>
-          <a:noFill/>
-          <a:ln/>
-        </p:spPr>
-        <p:txBody>
-          <a:bodyPr wrap="square" lIns="0" tIns="0" rIns="0" bIns="0" rtlCol="0" anchor="t"/>
-          <a:lstStyle/>
-          <a:p>
-            <a:pPr indent="0" marL="0">
-              <a:buNone/>
-            </a:pPr>
-            <a:r>
-              <a:rPr lang="en-US" sz="1500" dirty="0">
-                <a:solidFill>
-                  <a:srgbClr val="272425"/>
-                </a:solidFill>
-              </a:rPr>
-              <a:t>Decisiones claras, con opciones y avisos a tiempo cuando algo se sale de lo previsto</a:t>
+              <a:t>Compara las opciones con criterios y pesos explícitos, y muestra qué peso cambiaría la elección</a:t>
             </a:r>
             <a:endParaRPr lang="en-US" sz="1500" dirty="0"/>
           </a:p>
@@ -8742,18 +9988,142 @@
       </p:sp>
       <p:sp>
         <p:nvSpPr>
-          <p:cNvPr id="14" name="Shape 11"/>
+          <p:cNvPr id="16" name="Shape 12"/>
           <p:cNvSpPr/>
           <p:nvPr/>
         </p:nvSpPr>
         <p:spPr>
           <a:xfrm>
-            <a:off x="457200" y="3035808"/>
-            <a:ext cx="5541264" cy="1572768"/>
+            <a:off x="7726680" y="3954780"/>
+            <a:ext cx="4005072" cy="1035558"/>
           </a:xfrm>
           <a:prstGeom prst="roundRect">
             <a:avLst>
-              <a:gd name="adj" fmla="val 4651"/>
+              <a:gd name="adj" fmla="val 7064"/>
+            </a:avLst>
+          </a:prstGeom>
+          <a:solidFill>
+            <a:srgbClr val="E9F1F8"/>
+          </a:solidFill>
+          <a:ln w="9525">
+            <a:solidFill>
+              <a:srgbClr val="E9F1F8"/>
+            </a:solidFill>
+            <a:prstDash val="solid"/>
+          </a:ln>
+        </p:spPr>
+      </p:sp>
+      <p:sp>
+        <p:nvSpPr>
+          <p:cNvPr id="17" name="Shape 13"/>
+          <p:cNvSpPr/>
+          <p:nvPr/>
+        </p:nvSpPr>
+        <p:spPr>
+          <a:xfrm>
+            <a:off x="7891272" y="4271391"/>
+            <a:ext cx="402336" cy="402336"/>
+          </a:xfrm>
+          <a:prstGeom prst="ellipse">
+            <a:avLst/>
+          </a:prstGeom>
+          <a:solidFill>
+            <a:srgbClr val="17324D"/>
+          </a:solidFill>
+          <a:ln w="12700">
+            <a:solidFill>
+              <a:srgbClr val="17324D"/>
+            </a:solidFill>
+            <a:prstDash val="solid"/>
+          </a:ln>
+        </p:spPr>
+      </p:sp>
+      <p:sp>
+        <p:nvSpPr>
+          <p:cNvPr id="18" name="Text 14"/>
+          <p:cNvSpPr txBox="1"/>
+          <p:nvPr/>
+        </p:nvSpPr>
+        <p:spPr>
+          <a:xfrm>
+            <a:off x="7891272" y="4271391"/>
+            <a:ext cx="402336" cy="402336"/>
+          </a:xfrm>
+          <a:prstGeom prst="rect">
+            <a:avLst/>
+          </a:prstGeom>
+          <a:noFill/>
+          <a:ln/>
+        </p:spPr>
+        <p:txBody>
+          <a:bodyPr wrap="square" lIns="0" tIns="0" rIns="0" bIns="0" rtlCol="0" anchor="ctr"/>
+          <a:lstStyle/>
+          <a:p>
+            <a:pPr algn="ctr" indent="0" marL="0">
+              <a:buNone/>
+            </a:pPr>
+            <a:r>
+              <a:rPr lang="en-US" sz="1400" b="1" dirty="0">
+                <a:solidFill>
+                  <a:srgbClr val="FFFFFF"/>
+                </a:solidFill>
+              </a:rPr>
+              <a:t>3</a:t>
+            </a:r>
+            <a:endParaRPr lang="en-US" sz="1400" dirty="0"/>
+          </a:p>
+        </p:txBody>
+      </p:sp>
+      <p:sp>
+        <p:nvSpPr>
+          <p:cNvPr id="19" name="Text 15"/>
+          <p:cNvSpPr txBox="1"/>
+          <p:nvPr/>
+        </p:nvSpPr>
+        <p:spPr>
+          <a:xfrm>
+            <a:off x="8458200" y="4046220"/>
+            <a:ext cx="3108960" cy="852678"/>
+          </a:xfrm>
+          <a:prstGeom prst="rect">
+            <a:avLst/>
+          </a:prstGeom>
+          <a:noFill/>
+          <a:ln/>
+        </p:spPr>
+        <p:txBody>
+          <a:bodyPr wrap="square" lIns="0" tIns="0" rIns="0" bIns="0" rtlCol="0" anchor="ctr"/>
+          <a:lstStyle/>
+          <a:p>
+            <a:pPr indent="0" marL="0">
+              <a:buNone/>
+            </a:pPr>
+            <a:r>
+              <a:rPr lang="en-US" sz="1500" dirty="0">
+                <a:solidFill>
+                  <a:srgbClr val="17324D"/>
+                </a:solidFill>
+              </a:rPr>
+              <a:t>Decide la persona con la autoridad que corresponde; queda a la vista qué decisión sigue vigente</a:t>
+            </a:r>
+            <a:endParaRPr lang="en-US" sz="1500" dirty="0"/>
+          </a:p>
+        </p:txBody>
+      </p:sp>
+      <p:sp>
+        <p:nvSpPr>
+          <p:cNvPr id="20" name="Shape 16"/>
+          <p:cNvSpPr/>
+          <p:nvPr/>
+        </p:nvSpPr>
+        <p:spPr>
+          <a:xfrm>
+            <a:off x="7726680" y="5118354"/>
+            <a:ext cx="4005072" cy="1035558"/>
+          </a:xfrm>
+          <a:prstGeom prst="roundRect">
+            <a:avLst>
+              <a:gd name="adj" fmla="val 7064"/>
             </a:avLst>
           </a:prstGeom>
           <a:solidFill>
@@ -8769,14 +10139,14 @@
       </p:sp>
       <p:sp>
         <p:nvSpPr>
-          <p:cNvPr id="15" name="Shape 12"/>
+          <p:cNvPr id="21" name="Shape 17"/>
           <p:cNvSpPr/>
           <p:nvPr/>
         </p:nvSpPr>
         <p:spPr>
           <a:xfrm>
-            <a:off x="658368" y="3218688"/>
-            <a:ext cx="457200" cy="457200"/>
+            <a:off x="7891272" y="5434965"/>
+            <a:ext cx="402336" cy="402336"/>
           </a:xfrm>
           <a:prstGeom prst="ellipse">
             <a:avLst/>
@@ -8794,14 +10164,14 @@
       </p:sp>
       <p:sp>
         <p:nvSpPr>
-          <p:cNvPr id="16" name="Text 13"/>
-          <p:cNvSpPr txBox="1"/>
-          <p:nvPr/>
-        </p:nvSpPr>
-        <p:spPr>
-          <a:xfrm>
-            <a:off x="658368" y="3218688"/>
-            <a:ext cx="457200" cy="457200"/>
+          <p:cNvPr id="22" name="Text 18"/>
+          <p:cNvSpPr txBox="1"/>
+          <p:nvPr/>
+        </p:nvSpPr>
+        <p:spPr>
+          <a:xfrm>
+            <a:off x="7891272" y="5434965"/>
+            <a:ext cx="402336" cy="402336"/>
           </a:xfrm>
           <a:prstGeom prst="rect">
             <a:avLst/>
@@ -8817,27 +10187,27 @@
               <a:buNone/>
             </a:pPr>
             <a:r>
-              <a:rPr lang="en-US" sz="1600" b="1" dirty="0">
+              <a:rPr lang="en-US" sz="1400" b="1" dirty="0">
                 <a:solidFill>
                   <a:srgbClr val="FFFFFF"/>
                 </a:solidFill>
               </a:rPr>
-              <a:t>3</a:t>
-            </a:r>
-            <a:endParaRPr lang="en-US" sz="1600" dirty="0"/>
-          </a:p>
-        </p:txBody>
-      </p:sp>
-      <p:sp>
-        <p:nvSpPr>
-          <p:cNvPr id="17" name="Text 14"/>
-          <p:cNvSpPr txBox="1"/>
-          <p:nvPr/>
-        </p:nvSpPr>
-        <p:spPr>
-          <a:xfrm>
-            <a:off x="1280160" y="3218688"/>
-            <a:ext cx="4535424" cy="457200"/>
+              <a:t>4</a:t>
+            </a:r>
+            <a:endParaRPr lang="en-US" sz="1400" dirty="0"/>
+          </a:p>
+        </p:txBody>
+      </p:sp>
+      <p:sp>
+        <p:nvSpPr>
+          <p:cNvPr id="23" name="Text 19"/>
+          <p:cNvSpPr txBox="1"/>
+          <p:nvPr/>
+        </p:nvSpPr>
+        <p:spPr>
+          <a:xfrm>
+            <a:off x="8458200" y="5209794"/>
+            <a:ext cx="3108960" cy="852678"/>
           </a:xfrm>
           <a:prstGeom prst="rect">
             <a:avLst/>
@@ -8853,347 +10223,14 @@
               <a:buNone/>
             </a:pPr>
             <a:r>
-              <a:rPr lang="en-US" sz="1800" b="1" dirty="0">
+              <a:rPr lang="en-US" sz="1400" dirty="0">
                 <a:solidFill>
                   <a:srgbClr val="17324D"/>
                 </a:solidFill>
               </a:rPr>
-              <a:t>Equipo técnico o de producto</a:t>
-            </a:r>
-            <a:endParaRPr lang="en-US" sz="1800" dirty="0"/>
-          </a:p>
-        </p:txBody>
-      </p:sp>
-      <p:sp>
-        <p:nvSpPr>
-          <p:cNvPr id="18" name="Text 15"/>
-          <p:cNvSpPr txBox="1"/>
-          <p:nvPr/>
-        </p:nvSpPr>
-        <p:spPr>
-          <a:xfrm>
-            <a:off x="1280160" y="3749040"/>
-            <a:ext cx="4535424" cy="749808"/>
-          </a:xfrm>
-          <a:prstGeom prst="rect">
-            <a:avLst/>
-          </a:prstGeom>
-          <a:noFill/>
-          <a:ln/>
-        </p:spPr>
-        <p:txBody>
-          <a:bodyPr wrap="square" lIns="0" tIns="0" rIns="0" bIns="0" rtlCol="0" anchor="t"/>
-          <a:lstStyle/>
-          <a:p>
-            <a:pPr indent="0" marL="0">
-              <a:buNone/>
-            </a:pPr>
-            <a:r>
-              <a:rPr lang="en-US" sz="1500" dirty="0">
-                <a:solidFill>
-                  <a:srgbClr val="272425"/>
-                </a:solidFill>
-              </a:rPr>
-              <a:t>El plan sigue a los requisitos sin copiarlos; los cambios quedan a la vista</a:t>
-            </a:r>
-            <a:endParaRPr lang="en-US" sz="1500" dirty="0"/>
-          </a:p>
-        </p:txBody>
-      </p:sp>
-      <p:sp>
-        <p:nvSpPr>
-          <p:cNvPr id="19" name="Shape 16"/>
-          <p:cNvSpPr/>
-          <p:nvPr/>
-        </p:nvSpPr>
-        <p:spPr>
-          <a:xfrm>
-            <a:off x="6190488" y="3035808"/>
-            <a:ext cx="5541264" cy="1572768"/>
-          </a:xfrm>
-          <a:prstGeom prst="roundRect">
-            <a:avLst>
-              <a:gd name="adj" fmla="val 4651"/>
-            </a:avLst>
-          </a:prstGeom>
-          <a:solidFill>
-            <a:srgbClr val="E9F1F8"/>
-          </a:solidFill>
-          <a:ln w="9525">
-            <a:solidFill>
-              <a:srgbClr val="E9F1F8"/>
-            </a:solidFill>
-            <a:prstDash val="solid"/>
-          </a:ln>
-        </p:spPr>
-      </p:sp>
-      <p:sp>
-        <p:nvSpPr>
-          <p:cNvPr id="20" name="Shape 17"/>
-          <p:cNvSpPr/>
-          <p:nvPr/>
-        </p:nvSpPr>
-        <p:spPr>
-          <a:xfrm>
-            <a:off x="6391656" y="3218688"/>
-            <a:ext cx="457200" cy="457200"/>
-          </a:xfrm>
-          <a:prstGeom prst="ellipse">
-            <a:avLst/>
-          </a:prstGeom>
-          <a:solidFill>
-            <a:srgbClr val="17324D"/>
-          </a:solidFill>
-          <a:ln w="12700">
-            <a:solidFill>
-              <a:srgbClr val="17324D"/>
-            </a:solidFill>
-            <a:prstDash val="solid"/>
-          </a:ln>
-        </p:spPr>
-      </p:sp>
-      <p:sp>
-        <p:nvSpPr>
-          <p:cNvPr id="21" name="Text 18"/>
-          <p:cNvSpPr txBox="1"/>
-          <p:nvPr/>
-        </p:nvSpPr>
-        <p:spPr>
-          <a:xfrm>
-            <a:off x="6391656" y="3218688"/>
-            <a:ext cx="457200" cy="457200"/>
-          </a:xfrm>
-          <a:prstGeom prst="rect">
-            <a:avLst/>
-          </a:prstGeom>
-          <a:noFill/>
-          <a:ln/>
-        </p:spPr>
-        <p:txBody>
-          <a:bodyPr wrap="square" lIns="0" tIns="0" rIns="0" bIns="0" rtlCol="0" anchor="ctr"/>
-          <a:lstStyle/>
-          <a:p>
-            <a:pPr algn="ctr" indent="0" marL="0">
-              <a:buNone/>
-            </a:pPr>
-            <a:r>
-              <a:rPr lang="en-US" sz="1600" b="1" dirty="0">
-                <a:solidFill>
-                  <a:srgbClr val="FFFFFF"/>
-                </a:solidFill>
-              </a:rPr>
-              <a:t>4</a:t>
-            </a:r>
-            <a:endParaRPr lang="en-US" sz="1600" dirty="0"/>
-          </a:p>
-        </p:txBody>
-      </p:sp>
-      <p:sp>
-        <p:nvSpPr>
-          <p:cNvPr id="22" name="Text 19"/>
-          <p:cNvSpPr txBox="1"/>
-          <p:nvPr/>
-        </p:nvSpPr>
-        <p:spPr>
-          <a:xfrm>
-            <a:off x="7013448" y="3218688"/>
-            <a:ext cx="4535424" cy="457200"/>
-          </a:xfrm>
-          <a:prstGeom prst="rect">
-            <a:avLst/>
-          </a:prstGeom>
-          <a:noFill/>
-          <a:ln/>
-        </p:spPr>
-        <p:txBody>
-          <a:bodyPr wrap="square" lIns="0" tIns="0" rIns="0" bIns="0" rtlCol="0" anchor="ctr"/>
-          <a:lstStyle/>
-          <a:p>
-            <a:pPr indent="0" marL="0">
-              <a:buNone/>
-            </a:pPr>
-            <a:r>
-              <a:rPr lang="en-US" sz="1800" b="1" dirty="0">
-                <a:solidFill>
-                  <a:srgbClr val="17324D"/>
-                </a:solidFill>
-              </a:rPr>
-              <a:t>La organización</a:t>
-            </a:r>
-            <a:endParaRPr lang="en-US" sz="1800" dirty="0"/>
-          </a:p>
-        </p:txBody>
-      </p:sp>
-      <p:sp>
-        <p:nvSpPr>
-          <p:cNvPr id="23" name="Text 20"/>
-          <p:cNvSpPr txBox="1"/>
-          <p:nvPr/>
-        </p:nvSpPr>
-        <p:spPr>
-          <a:xfrm>
-            <a:off x="7013448" y="3749040"/>
-            <a:ext cx="4535424" cy="749808"/>
-          </a:xfrm>
-          <a:prstGeom prst="rect">
-            <a:avLst/>
-          </a:prstGeom>
-          <a:noFill/>
-          <a:ln/>
-        </p:spPr>
-        <p:txBody>
-          <a:bodyPr wrap="square" lIns="0" tIns="0" rIns="0" bIns="0" rtlCol="0" anchor="t"/>
-          <a:lstStyle/>
-          <a:p>
-            <a:pPr indent="0" marL="0">
-              <a:buNone/>
-            </a:pPr>
-            <a:r>
-              <a:rPr lang="en-US" sz="1500" dirty="0">
-                <a:solidFill>
-                  <a:srgbClr val="272425"/>
-                </a:solidFill>
-              </a:rPr>
-              <a:t>Un estándar repetible y auditable: cada decisión, con su fuente y su registro</a:t>
-            </a:r>
-            <a:endParaRPr lang="en-US" sz="1500" dirty="0"/>
-          </a:p>
-        </p:txBody>
-      </p:sp>
-      <p:sp>
-        <p:nvSpPr>
-          <p:cNvPr id="24" name="Shape 21"/>
-          <p:cNvSpPr/>
-          <p:nvPr/>
-        </p:nvSpPr>
-        <p:spPr>
-          <a:xfrm>
-            <a:off x="457200" y="4828032"/>
-            <a:ext cx="11274552" cy="640080"/>
-          </a:xfrm>
-          <a:prstGeom prst="roundRect">
-            <a:avLst>
-              <a:gd name="adj" fmla="val 11429"/>
-            </a:avLst>
-          </a:prstGeom>
-          <a:solidFill>
-            <a:srgbClr val="17324D"/>
-          </a:solidFill>
-          <a:ln w="9525">
-            <a:solidFill>
-              <a:srgbClr val="17324D"/>
-            </a:solidFill>
-            <a:prstDash val="solid"/>
-          </a:ln>
-        </p:spPr>
-      </p:sp>
-      <p:sp>
-        <p:nvSpPr>
-          <p:cNvPr id="25" name="Text 22"/>
-          <p:cNvSpPr txBox="1"/>
-          <p:nvPr/>
-        </p:nvSpPr>
-        <p:spPr>
-          <a:xfrm>
-            <a:off x="685800" y="4828032"/>
-            <a:ext cx="10881360" cy="640080"/>
-          </a:xfrm>
-          <a:prstGeom prst="rect">
-            <a:avLst/>
-          </a:prstGeom>
-          <a:noFill/>
-          <a:ln/>
-        </p:spPr>
-        <p:txBody>
-          <a:bodyPr wrap="square" lIns="0" tIns="0" rIns="0" bIns="0" rtlCol="0" anchor="ctr"/>
-          <a:lstStyle/>
-          <a:p>
-            <a:pPr indent="0" marL="0">
-              <a:buNone/>
-            </a:pPr>
-            <a:r>
-              <a:rPr lang="en-US" sz="1800" b="1" dirty="0">
-                <a:solidFill>
-                  <a:srgbClr val="9FD0F0"/>
-                </a:solidFill>
-              </a:rPr>
-              <a:t>✓  </a:t>
-            </a:r>
-            <a:pPr indent="0" marL="0">
-              <a:buNone/>
-            </a:pPr>
-            <a:r>
-              <a:rPr lang="en-US" sz="1500" b="1" dirty="0">
-                <a:solidFill>
-                  <a:srgbClr val="FFFFFF"/>
-                </a:solidFill>
-              </a:rPr>
-              <a:t>Calidad verificada (2026-10-27): 355 pruebas automáticas sin fallos y 5 recorridos completos reproducibles</a:t>
+              <a:t>Buscador opcional: preguntas en español o inglés sobre todo el proyecto, con la cita de cada respuesta</a:t>
             </a:r>
             <a:endParaRPr lang="en-US" sz="1400" dirty="0"/>
-          </a:p>
-        </p:txBody>
-      </p:sp>
-      <p:sp>
-        <p:nvSpPr>
-          <p:cNvPr id="26" name="Shape 23"/>
-          <p:cNvSpPr/>
-          <p:nvPr/>
-        </p:nvSpPr>
-        <p:spPr>
-          <a:xfrm>
-            <a:off x="457200" y="5596128"/>
-            <a:ext cx="11274552" cy="548640"/>
-          </a:xfrm>
-          <a:prstGeom prst="roundRect">
-            <a:avLst>
-              <a:gd name="adj" fmla="val 13333"/>
-            </a:avLst>
-          </a:prstGeom>
-          <a:solidFill>
-            <a:srgbClr val="F4F6F8"/>
-          </a:solidFill>
-          <a:ln w="9525">
-            <a:solidFill>
-              <a:srgbClr val="F4F6F8"/>
-            </a:solidFill>
-            <a:prstDash val="solid"/>
-          </a:ln>
-        </p:spPr>
-      </p:sp>
-      <p:sp>
-        <p:nvSpPr>
-          <p:cNvPr id="27" name="Text 24"/>
-          <p:cNvSpPr txBox="1"/>
-          <p:nvPr/>
-        </p:nvSpPr>
-        <p:spPr>
-          <a:xfrm>
-            <a:off x="685800" y="5596128"/>
-            <a:ext cx="10881360" cy="548640"/>
-          </a:xfrm>
-          <a:prstGeom prst="rect">
-            <a:avLst/>
-          </a:prstGeom>
-          <a:noFill/>
-          <a:ln/>
-        </p:spPr>
-        <p:txBody>
-          <a:bodyPr wrap="square" lIns="0" tIns="0" rIns="0" bIns="0" rtlCol="0" anchor="ctr"/>
-          <a:lstStyle/>
-          <a:p>
-            <a:pPr indent="0" marL="0">
-              <a:buNone/>
-            </a:pPr>
-            <a:r>
-              <a:rPr lang="en-US" sz="1500" dirty="0">
-                <a:solidFill>
-                  <a:srgbClr val="17324D"/>
-                </a:solidFill>
-              </a:rPr>
-              <a:t>Abierto: licencia MIT; los datos son archivos de texto que se leen sin pm-method</a:t>
-            </a:r>
-            <a:endParaRPr lang="en-US" sz="1500" dirty="0"/>
           </a:p>
         </p:txBody>
       </p:sp>
@@ -9299,7 +10336,7 @@
                   <a:srgbClr val="FFFFFF"/>
                 </a:solidFill>
               </a:rPr>
-              <a:t>Qué falta y cómo seguir: un piloto real, con usuarios y herramientas reales</a:t>
+              <a:t>Ventajas: decisiones trazables, datos que cuadran y menos trabajo administrativo</a:t>
             </a:r>
             <a:endParaRPr lang="en-US" sz="1900" dirty="0"/>
           </a:p>
@@ -9314,11 +10351,725 @@
         <p:spPr>
           <a:xfrm>
             <a:off x="457200" y="1298448"/>
-            <a:ext cx="5541264" cy="4114800"/>
+            <a:ext cx="5541264" cy="1572768"/>
           </a:xfrm>
           <a:prstGeom prst="roundRect">
             <a:avLst>
-              <a:gd name="adj" fmla="val 1778"/>
+              <a:gd name="adj" fmla="val 4651"/>
+            </a:avLst>
+          </a:prstGeom>
+          <a:solidFill>
+            <a:srgbClr val="E9F1F8"/>
+          </a:solidFill>
+          <a:ln w="9525">
+            <a:solidFill>
+              <a:srgbClr val="E9F1F8"/>
+            </a:solidFill>
+            <a:prstDash val="solid"/>
+          </a:ln>
+        </p:spPr>
+      </p:sp>
+      <p:sp>
+        <p:nvSpPr>
+          <p:cNvPr id="5" name="Shape 2"/>
+          <p:cNvSpPr/>
+          <p:nvPr/>
+        </p:nvSpPr>
+        <p:spPr>
+          <a:xfrm>
+            <a:off x="658368" y="1481328"/>
+            <a:ext cx="457200" cy="457200"/>
+          </a:xfrm>
+          <a:prstGeom prst="ellipse">
+            <a:avLst/>
+          </a:prstGeom>
+          <a:solidFill>
+            <a:srgbClr val="17324D"/>
+          </a:solidFill>
+          <a:ln w="12700">
+            <a:solidFill>
+              <a:srgbClr val="17324D"/>
+            </a:solidFill>
+            <a:prstDash val="solid"/>
+          </a:ln>
+        </p:spPr>
+      </p:sp>
+      <p:sp>
+        <p:nvSpPr>
+          <p:cNvPr id="6" name="Text 3"/>
+          <p:cNvSpPr txBox="1"/>
+          <p:nvPr/>
+        </p:nvSpPr>
+        <p:spPr>
+          <a:xfrm>
+            <a:off x="658368" y="1481328"/>
+            <a:ext cx="457200" cy="457200"/>
+          </a:xfrm>
+          <a:prstGeom prst="rect">
+            <a:avLst/>
+          </a:prstGeom>
+          <a:noFill/>
+          <a:ln/>
+        </p:spPr>
+        <p:txBody>
+          <a:bodyPr wrap="square" lIns="0" tIns="0" rIns="0" bIns="0" rtlCol="0" anchor="ctr"/>
+          <a:lstStyle/>
+          <a:p>
+            <a:pPr algn="ctr" indent="0" marL="0">
+              <a:buNone/>
+            </a:pPr>
+            <a:r>
+              <a:rPr lang="en-US" sz="1600" b="1" dirty="0">
+                <a:solidFill>
+                  <a:srgbClr val="FFFFFF"/>
+                </a:solidFill>
+              </a:rPr>
+              <a:t>1</a:t>
+            </a:r>
+            <a:endParaRPr lang="en-US" sz="1600" dirty="0"/>
+          </a:p>
+        </p:txBody>
+      </p:sp>
+      <p:sp>
+        <p:nvSpPr>
+          <p:cNvPr id="7" name="Text 4"/>
+          <p:cNvSpPr txBox="1"/>
+          <p:nvPr/>
+        </p:nvSpPr>
+        <p:spPr>
+          <a:xfrm>
+            <a:off x="1280160" y="1481328"/>
+            <a:ext cx="4535424" cy="457200"/>
+          </a:xfrm>
+          <a:prstGeom prst="rect">
+            <a:avLst/>
+          </a:prstGeom>
+          <a:noFill/>
+          <a:ln/>
+        </p:spPr>
+        <p:txBody>
+          <a:bodyPr wrap="square" lIns="0" tIns="0" rIns="0" bIns="0" rtlCol="0" anchor="ctr"/>
+          <a:lstStyle/>
+          <a:p>
+            <a:pPr indent="0" marL="0">
+              <a:buNone/>
+            </a:pPr>
+            <a:r>
+              <a:rPr lang="en-US" sz="1800" b="1" dirty="0">
+                <a:solidFill>
+                  <a:srgbClr val="17324D"/>
+                </a:solidFill>
+              </a:rPr>
+              <a:t>Quien gestiona proyectos</a:t>
+            </a:r>
+            <a:endParaRPr lang="en-US" sz="1800" dirty="0"/>
+          </a:p>
+        </p:txBody>
+      </p:sp>
+      <p:sp>
+        <p:nvSpPr>
+          <p:cNvPr id="8" name="Text 5"/>
+          <p:cNvSpPr txBox="1"/>
+          <p:nvPr/>
+        </p:nvSpPr>
+        <p:spPr>
+          <a:xfrm>
+            <a:off x="1280160" y="2011680"/>
+            <a:ext cx="4535424" cy="749808"/>
+          </a:xfrm>
+          <a:prstGeom prst="rect">
+            <a:avLst/>
+          </a:prstGeom>
+          <a:noFill/>
+          <a:ln/>
+        </p:spPr>
+        <p:txBody>
+          <a:bodyPr wrap="square" lIns="0" tIns="0" rIns="0" bIns="0" rtlCol="0" anchor="t"/>
+          <a:lstStyle/>
+          <a:p>
+            <a:pPr indent="0" marL="0">
+              <a:buNone/>
+            </a:pPr>
+            <a:r>
+              <a:rPr lang="en-US" sz="1500" dirty="0">
+                <a:solidFill>
+                  <a:srgbClr val="272425"/>
+                </a:solidFill>
+              </a:rPr>
+              <a:t>Planes, registros e informes preparados con método; menos tiempo armando documentos</a:t>
+            </a:r>
+            <a:endParaRPr lang="en-US" sz="1500" dirty="0"/>
+          </a:p>
+        </p:txBody>
+      </p:sp>
+      <p:sp>
+        <p:nvSpPr>
+          <p:cNvPr id="9" name="Shape 6"/>
+          <p:cNvSpPr/>
+          <p:nvPr/>
+        </p:nvSpPr>
+        <p:spPr>
+          <a:xfrm>
+            <a:off x="6190488" y="1298448"/>
+            <a:ext cx="5541264" cy="1572768"/>
+          </a:xfrm>
+          <a:prstGeom prst="roundRect">
+            <a:avLst>
+              <a:gd name="adj" fmla="val 4651"/>
+            </a:avLst>
+          </a:prstGeom>
+          <a:solidFill>
+            <a:srgbClr val="FBF1E6"/>
+          </a:solidFill>
+          <a:ln w="9525">
+            <a:solidFill>
+              <a:srgbClr val="FBF1E6"/>
+            </a:solidFill>
+            <a:prstDash val="solid"/>
+          </a:ln>
+        </p:spPr>
+      </p:sp>
+      <p:sp>
+        <p:nvSpPr>
+          <p:cNvPr id="10" name="Shape 7"/>
+          <p:cNvSpPr/>
+          <p:nvPr/>
+        </p:nvSpPr>
+        <p:spPr>
+          <a:xfrm>
+            <a:off x="6391656" y="1481328"/>
+            <a:ext cx="457200" cy="457200"/>
+          </a:xfrm>
+          <a:prstGeom prst="ellipse">
+            <a:avLst/>
+          </a:prstGeom>
+          <a:solidFill>
+            <a:srgbClr val="B5651D"/>
+          </a:solidFill>
+          <a:ln w="12700">
+            <a:solidFill>
+              <a:srgbClr val="B5651D"/>
+            </a:solidFill>
+            <a:prstDash val="solid"/>
+          </a:ln>
+        </p:spPr>
+      </p:sp>
+      <p:sp>
+        <p:nvSpPr>
+          <p:cNvPr id="11" name="Text 8"/>
+          <p:cNvSpPr txBox="1"/>
+          <p:nvPr/>
+        </p:nvSpPr>
+        <p:spPr>
+          <a:xfrm>
+            <a:off x="6391656" y="1481328"/>
+            <a:ext cx="457200" cy="457200"/>
+          </a:xfrm>
+          <a:prstGeom prst="rect">
+            <a:avLst/>
+          </a:prstGeom>
+          <a:noFill/>
+          <a:ln/>
+        </p:spPr>
+        <p:txBody>
+          <a:bodyPr wrap="square" lIns="0" tIns="0" rIns="0" bIns="0" rtlCol="0" anchor="ctr"/>
+          <a:lstStyle/>
+          <a:p>
+            <a:pPr algn="ctr" indent="0" marL="0">
+              <a:buNone/>
+            </a:pPr>
+            <a:r>
+              <a:rPr lang="en-US" sz="1600" b="1" dirty="0">
+                <a:solidFill>
+                  <a:srgbClr val="FFFFFF"/>
+                </a:solidFill>
+              </a:rPr>
+              <a:t>2</a:t>
+            </a:r>
+            <a:endParaRPr lang="en-US" sz="1600" dirty="0"/>
+          </a:p>
+        </p:txBody>
+      </p:sp>
+      <p:sp>
+        <p:nvSpPr>
+          <p:cNvPr id="12" name="Text 9"/>
+          <p:cNvSpPr txBox="1"/>
+          <p:nvPr/>
+        </p:nvSpPr>
+        <p:spPr>
+          <a:xfrm>
+            <a:off x="7013448" y="1481328"/>
+            <a:ext cx="4535424" cy="457200"/>
+          </a:xfrm>
+          <a:prstGeom prst="rect">
+            <a:avLst/>
+          </a:prstGeom>
+          <a:noFill/>
+          <a:ln/>
+        </p:spPr>
+        <p:txBody>
+          <a:bodyPr wrap="square" lIns="0" tIns="0" rIns="0" bIns="0" rtlCol="0" anchor="ctr"/>
+          <a:lstStyle/>
+          <a:p>
+            <a:pPr indent="0" marL="0">
+              <a:buNone/>
+            </a:pPr>
+            <a:r>
+              <a:rPr lang="en-US" sz="1800" b="1" dirty="0">
+                <a:solidFill>
+                  <a:srgbClr val="17324D"/>
+                </a:solidFill>
+              </a:rPr>
+              <a:t>Quien dirige o patrocina</a:t>
+            </a:r>
+            <a:endParaRPr lang="en-US" sz="1800" dirty="0"/>
+          </a:p>
+        </p:txBody>
+      </p:sp>
+      <p:sp>
+        <p:nvSpPr>
+          <p:cNvPr id="13" name="Text 10"/>
+          <p:cNvSpPr txBox="1"/>
+          <p:nvPr/>
+        </p:nvSpPr>
+        <p:spPr>
+          <a:xfrm>
+            <a:off x="7013448" y="2011680"/>
+            <a:ext cx="4535424" cy="749808"/>
+          </a:xfrm>
+          <a:prstGeom prst="rect">
+            <a:avLst/>
+          </a:prstGeom>
+          <a:noFill/>
+          <a:ln/>
+        </p:spPr>
+        <p:txBody>
+          <a:bodyPr wrap="square" lIns="0" tIns="0" rIns="0" bIns="0" rtlCol="0" anchor="t"/>
+          <a:lstStyle/>
+          <a:p>
+            <a:pPr indent="0" marL="0">
+              <a:buNone/>
+            </a:pPr>
+            <a:r>
+              <a:rPr lang="en-US" sz="1500" dirty="0">
+                <a:solidFill>
+                  <a:srgbClr val="272425"/>
+                </a:solidFill>
+              </a:rPr>
+              <a:t>Decisiones claras, con opciones y avisos a tiempo cuando algo se sale de lo previsto</a:t>
+            </a:r>
+            <a:endParaRPr lang="en-US" sz="1500" dirty="0"/>
+          </a:p>
+        </p:txBody>
+      </p:sp>
+      <p:sp>
+        <p:nvSpPr>
+          <p:cNvPr id="14" name="Shape 11"/>
+          <p:cNvSpPr/>
+          <p:nvPr/>
+        </p:nvSpPr>
+        <p:spPr>
+          <a:xfrm>
+            <a:off x="457200" y="3035808"/>
+            <a:ext cx="5541264" cy="1572768"/>
+          </a:xfrm>
+          <a:prstGeom prst="roundRect">
+            <a:avLst>
+              <a:gd name="adj" fmla="val 4651"/>
+            </a:avLst>
+          </a:prstGeom>
+          <a:solidFill>
+            <a:srgbClr val="FBF1E6"/>
+          </a:solidFill>
+          <a:ln w="9525">
+            <a:solidFill>
+              <a:srgbClr val="FBF1E6"/>
+            </a:solidFill>
+            <a:prstDash val="solid"/>
+          </a:ln>
+        </p:spPr>
+      </p:sp>
+      <p:sp>
+        <p:nvSpPr>
+          <p:cNvPr id="15" name="Shape 12"/>
+          <p:cNvSpPr/>
+          <p:nvPr/>
+        </p:nvSpPr>
+        <p:spPr>
+          <a:xfrm>
+            <a:off x="658368" y="3218688"/>
+            <a:ext cx="457200" cy="457200"/>
+          </a:xfrm>
+          <a:prstGeom prst="ellipse">
+            <a:avLst/>
+          </a:prstGeom>
+          <a:solidFill>
+            <a:srgbClr val="B5651D"/>
+          </a:solidFill>
+          <a:ln w="12700">
+            <a:solidFill>
+              <a:srgbClr val="B5651D"/>
+            </a:solidFill>
+            <a:prstDash val="solid"/>
+          </a:ln>
+        </p:spPr>
+      </p:sp>
+      <p:sp>
+        <p:nvSpPr>
+          <p:cNvPr id="16" name="Text 13"/>
+          <p:cNvSpPr txBox="1"/>
+          <p:nvPr/>
+        </p:nvSpPr>
+        <p:spPr>
+          <a:xfrm>
+            <a:off x="658368" y="3218688"/>
+            <a:ext cx="457200" cy="457200"/>
+          </a:xfrm>
+          <a:prstGeom prst="rect">
+            <a:avLst/>
+          </a:prstGeom>
+          <a:noFill/>
+          <a:ln/>
+        </p:spPr>
+        <p:txBody>
+          <a:bodyPr wrap="square" lIns="0" tIns="0" rIns="0" bIns="0" rtlCol="0" anchor="ctr"/>
+          <a:lstStyle/>
+          <a:p>
+            <a:pPr algn="ctr" indent="0" marL="0">
+              <a:buNone/>
+            </a:pPr>
+            <a:r>
+              <a:rPr lang="en-US" sz="1600" b="1" dirty="0">
+                <a:solidFill>
+                  <a:srgbClr val="FFFFFF"/>
+                </a:solidFill>
+              </a:rPr>
+              <a:t>3</a:t>
+            </a:r>
+            <a:endParaRPr lang="en-US" sz="1600" dirty="0"/>
+          </a:p>
+        </p:txBody>
+      </p:sp>
+      <p:sp>
+        <p:nvSpPr>
+          <p:cNvPr id="17" name="Text 14"/>
+          <p:cNvSpPr txBox="1"/>
+          <p:nvPr/>
+        </p:nvSpPr>
+        <p:spPr>
+          <a:xfrm>
+            <a:off x="1280160" y="3218688"/>
+            <a:ext cx="4535424" cy="457200"/>
+          </a:xfrm>
+          <a:prstGeom prst="rect">
+            <a:avLst/>
+          </a:prstGeom>
+          <a:noFill/>
+          <a:ln/>
+        </p:spPr>
+        <p:txBody>
+          <a:bodyPr wrap="square" lIns="0" tIns="0" rIns="0" bIns="0" rtlCol="0" anchor="ctr"/>
+          <a:lstStyle/>
+          <a:p>
+            <a:pPr indent="0" marL="0">
+              <a:buNone/>
+            </a:pPr>
+            <a:r>
+              <a:rPr lang="en-US" sz="1800" b="1" dirty="0">
+                <a:solidFill>
+                  <a:srgbClr val="17324D"/>
+                </a:solidFill>
+              </a:rPr>
+              <a:t>Equipo técnico o de producto</a:t>
+            </a:r>
+            <a:endParaRPr lang="en-US" sz="1800" dirty="0"/>
+          </a:p>
+        </p:txBody>
+      </p:sp>
+      <p:sp>
+        <p:nvSpPr>
+          <p:cNvPr id="18" name="Text 15"/>
+          <p:cNvSpPr txBox="1"/>
+          <p:nvPr/>
+        </p:nvSpPr>
+        <p:spPr>
+          <a:xfrm>
+            <a:off x="1280160" y="3749040"/>
+            <a:ext cx="4535424" cy="749808"/>
+          </a:xfrm>
+          <a:prstGeom prst="rect">
+            <a:avLst/>
+          </a:prstGeom>
+          <a:noFill/>
+          <a:ln/>
+        </p:spPr>
+        <p:txBody>
+          <a:bodyPr wrap="square" lIns="0" tIns="0" rIns="0" bIns="0" rtlCol="0" anchor="t"/>
+          <a:lstStyle/>
+          <a:p>
+            <a:pPr indent="0" marL="0">
+              <a:buNone/>
+            </a:pPr>
+            <a:r>
+              <a:rPr lang="en-US" sz="1500" dirty="0">
+                <a:solidFill>
+                  <a:srgbClr val="272425"/>
+                </a:solidFill>
+              </a:rPr>
+              <a:t>El plan sigue a los requisitos sin copiarlos; los cambios quedan a la vista</a:t>
+            </a:r>
+            <a:endParaRPr lang="en-US" sz="1500" dirty="0"/>
+          </a:p>
+        </p:txBody>
+      </p:sp>
+      <p:sp>
+        <p:nvSpPr>
+          <p:cNvPr id="19" name="Shape 16"/>
+          <p:cNvSpPr/>
+          <p:nvPr/>
+        </p:nvSpPr>
+        <p:spPr>
+          <a:xfrm>
+            <a:off x="6190488" y="3035808"/>
+            <a:ext cx="5541264" cy="1572768"/>
+          </a:xfrm>
+          <a:prstGeom prst="roundRect">
+            <a:avLst>
+              <a:gd name="adj" fmla="val 4651"/>
+            </a:avLst>
+          </a:prstGeom>
+          <a:solidFill>
+            <a:srgbClr val="E9F1F8"/>
+          </a:solidFill>
+          <a:ln w="9525">
+            <a:solidFill>
+              <a:srgbClr val="E9F1F8"/>
+            </a:solidFill>
+            <a:prstDash val="solid"/>
+          </a:ln>
+        </p:spPr>
+      </p:sp>
+      <p:sp>
+        <p:nvSpPr>
+          <p:cNvPr id="20" name="Shape 17"/>
+          <p:cNvSpPr/>
+          <p:nvPr/>
+        </p:nvSpPr>
+        <p:spPr>
+          <a:xfrm>
+            <a:off x="6391656" y="3218688"/>
+            <a:ext cx="457200" cy="457200"/>
+          </a:xfrm>
+          <a:prstGeom prst="ellipse">
+            <a:avLst/>
+          </a:prstGeom>
+          <a:solidFill>
+            <a:srgbClr val="17324D"/>
+          </a:solidFill>
+          <a:ln w="12700">
+            <a:solidFill>
+              <a:srgbClr val="17324D"/>
+            </a:solidFill>
+            <a:prstDash val="solid"/>
+          </a:ln>
+        </p:spPr>
+      </p:sp>
+      <p:sp>
+        <p:nvSpPr>
+          <p:cNvPr id="21" name="Text 18"/>
+          <p:cNvSpPr txBox="1"/>
+          <p:nvPr/>
+        </p:nvSpPr>
+        <p:spPr>
+          <a:xfrm>
+            <a:off x="6391656" y="3218688"/>
+            <a:ext cx="457200" cy="457200"/>
+          </a:xfrm>
+          <a:prstGeom prst="rect">
+            <a:avLst/>
+          </a:prstGeom>
+          <a:noFill/>
+          <a:ln/>
+        </p:spPr>
+        <p:txBody>
+          <a:bodyPr wrap="square" lIns="0" tIns="0" rIns="0" bIns="0" rtlCol="0" anchor="ctr"/>
+          <a:lstStyle/>
+          <a:p>
+            <a:pPr algn="ctr" indent="0" marL="0">
+              <a:buNone/>
+            </a:pPr>
+            <a:r>
+              <a:rPr lang="en-US" sz="1600" b="1" dirty="0">
+                <a:solidFill>
+                  <a:srgbClr val="FFFFFF"/>
+                </a:solidFill>
+              </a:rPr>
+              <a:t>4</a:t>
+            </a:r>
+            <a:endParaRPr lang="en-US" sz="1600" dirty="0"/>
+          </a:p>
+        </p:txBody>
+      </p:sp>
+      <p:sp>
+        <p:nvSpPr>
+          <p:cNvPr id="22" name="Text 19"/>
+          <p:cNvSpPr txBox="1"/>
+          <p:nvPr/>
+        </p:nvSpPr>
+        <p:spPr>
+          <a:xfrm>
+            <a:off x="7013448" y="3218688"/>
+            <a:ext cx="4535424" cy="457200"/>
+          </a:xfrm>
+          <a:prstGeom prst="rect">
+            <a:avLst/>
+          </a:prstGeom>
+          <a:noFill/>
+          <a:ln/>
+        </p:spPr>
+        <p:txBody>
+          <a:bodyPr wrap="square" lIns="0" tIns="0" rIns="0" bIns="0" rtlCol="0" anchor="ctr"/>
+          <a:lstStyle/>
+          <a:p>
+            <a:pPr indent="0" marL="0">
+              <a:buNone/>
+            </a:pPr>
+            <a:r>
+              <a:rPr lang="en-US" sz="1800" b="1" dirty="0">
+                <a:solidFill>
+                  <a:srgbClr val="17324D"/>
+                </a:solidFill>
+              </a:rPr>
+              <a:t>La organización</a:t>
+            </a:r>
+            <a:endParaRPr lang="en-US" sz="1800" dirty="0"/>
+          </a:p>
+        </p:txBody>
+      </p:sp>
+      <p:sp>
+        <p:nvSpPr>
+          <p:cNvPr id="23" name="Text 20"/>
+          <p:cNvSpPr txBox="1"/>
+          <p:nvPr/>
+        </p:nvSpPr>
+        <p:spPr>
+          <a:xfrm>
+            <a:off x="7013448" y="3749040"/>
+            <a:ext cx="4535424" cy="749808"/>
+          </a:xfrm>
+          <a:prstGeom prst="rect">
+            <a:avLst/>
+          </a:prstGeom>
+          <a:noFill/>
+          <a:ln/>
+        </p:spPr>
+        <p:txBody>
+          <a:bodyPr wrap="square" lIns="0" tIns="0" rIns="0" bIns="0" rtlCol="0" anchor="t"/>
+          <a:lstStyle/>
+          <a:p>
+            <a:pPr indent="0" marL="0">
+              <a:buNone/>
+            </a:pPr>
+            <a:r>
+              <a:rPr lang="en-US" sz="1500" dirty="0">
+                <a:solidFill>
+                  <a:srgbClr val="272425"/>
+                </a:solidFill>
+              </a:rPr>
+              <a:t>Un estándar repetible y auditable: cada decisión, con su fuente y su registro</a:t>
+            </a:r>
+            <a:endParaRPr lang="en-US" sz="1500" dirty="0"/>
+          </a:p>
+        </p:txBody>
+      </p:sp>
+      <p:sp>
+        <p:nvSpPr>
+          <p:cNvPr id="24" name="Shape 21"/>
+          <p:cNvSpPr/>
+          <p:nvPr/>
+        </p:nvSpPr>
+        <p:spPr>
+          <a:xfrm>
+            <a:off x="457200" y="4828032"/>
+            <a:ext cx="11274552" cy="640080"/>
+          </a:xfrm>
+          <a:prstGeom prst="roundRect">
+            <a:avLst>
+              <a:gd name="adj" fmla="val 11429"/>
+            </a:avLst>
+          </a:prstGeom>
+          <a:solidFill>
+            <a:srgbClr val="17324D"/>
+          </a:solidFill>
+          <a:ln w="9525">
+            <a:solidFill>
+              <a:srgbClr val="17324D"/>
+            </a:solidFill>
+            <a:prstDash val="solid"/>
+          </a:ln>
+        </p:spPr>
+      </p:sp>
+      <p:sp>
+        <p:nvSpPr>
+          <p:cNvPr id="25" name="Text 22"/>
+          <p:cNvSpPr txBox="1"/>
+          <p:nvPr/>
+        </p:nvSpPr>
+        <p:spPr>
+          <a:xfrm>
+            <a:off x="685800" y="4828032"/>
+            <a:ext cx="10881360" cy="640080"/>
+          </a:xfrm>
+          <a:prstGeom prst="rect">
+            <a:avLst/>
+          </a:prstGeom>
+          <a:noFill/>
+          <a:ln/>
+        </p:spPr>
+        <p:txBody>
+          <a:bodyPr wrap="square" lIns="0" tIns="0" rIns="0" bIns="0" rtlCol="0" anchor="ctr"/>
+          <a:lstStyle/>
+          <a:p>
+            <a:pPr indent="0" marL="0">
+              <a:buNone/>
+            </a:pPr>
+            <a:r>
+              <a:rPr lang="en-US" sz="1800" b="1" dirty="0">
+                <a:solidFill>
+                  <a:srgbClr val="9FD0F0"/>
+                </a:solidFill>
+              </a:rPr>
+              <a:t>✓  </a:t>
+            </a:r>
+            <a:pPr indent="0" marL="0">
+              <a:buNone/>
+            </a:pPr>
+            <a:r>
+              <a:rPr lang="en-US" sz="1500" b="1" dirty="0">
+                <a:solidFill>
+                  <a:srgbClr val="FFFFFF"/>
+                </a:solidFill>
+              </a:rPr>
+              <a:t>Calidad verificada (2026-10-29): 463 pruebas automáticas sin fallos y 5 recorridos completos reproducibles</a:t>
+            </a:r>
+            <a:endParaRPr lang="en-US" sz="1400" dirty="0"/>
+          </a:p>
+        </p:txBody>
+      </p:sp>
+      <p:sp>
+        <p:nvSpPr>
+          <p:cNvPr id="26" name="Shape 23"/>
+          <p:cNvSpPr/>
+          <p:nvPr/>
+        </p:nvSpPr>
+        <p:spPr>
+          <a:xfrm>
+            <a:off x="457200" y="5596128"/>
+            <a:ext cx="11274552" cy="548640"/>
+          </a:xfrm>
+          <a:prstGeom prst="roundRect">
+            <a:avLst>
+              <a:gd name="adj" fmla="val 13333"/>
             </a:avLst>
           </a:prstGeom>
           <a:solidFill>
@@ -9334,974 +11085,37 @@
       </p:sp>
       <p:sp>
         <p:nvSpPr>
-          <p:cNvPr id="5" name="Text 2"/>
-          <p:cNvSpPr txBox="1"/>
-          <p:nvPr/>
-        </p:nvSpPr>
-        <p:spPr>
-          <a:xfrm>
-            <a:off x="658368" y="1463040"/>
-            <a:ext cx="5175504" cy="256032"/>
-          </a:xfrm>
-          <a:prstGeom prst="rect">
-            <a:avLst/>
-          </a:prstGeom>
-          <a:noFill/>
-          <a:ln/>
-        </p:spPr>
-        <p:txBody>
-          <a:bodyPr wrap="square" lIns="0" tIns="0" rIns="0" bIns="0" rtlCol="0" anchor="t"/>
-          <a:lstStyle/>
-          <a:p>
-            <a:pPr indent="0" marL="0">
-              <a:buNone/>
-            </a:pPr>
-            <a:r>
-              <a:rPr lang="en-US" sz="1100" b="1" spc="100" kern="0" dirty="0">
+          <p:cNvPr id="27" name="Text 24"/>
+          <p:cNvSpPr txBox="1"/>
+          <p:nvPr/>
+        </p:nvSpPr>
+        <p:spPr>
+          <a:xfrm>
+            <a:off x="685800" y="5596128"/>
+            <a:ext cx="10881360" cy="548640"/>
+          </a:xfrm>
+          <a:prstGeom prst="rect">
+            <a:avLst/>
+          </a:prstGeom>
+          <a:noFill/>
+          <a:ln/>
+        </p:spPr>
+        <p:txBody>
+          <a:bodyPr wrap="square" lIns="0" tIns="0" rIns="0" bIns="0" rtlCol="0" anchor="ctr"/>
+          <a:lstStyle/>
+          <a:p>
+            <a:pPr indent="0" marL="0">
+              <a:buNone/>
+            </a:pPr>
+            <a:r>
+              <a:rPr lang="en-US" sz="1500" dirty="0">
                 <a:solidFill>
                   <a:srgbClr val="17324D"/>
                 </a:solidFill>
               </a:rPr>
-              <a:t>LÍMITES CONOCIDOS, CON HONESTIDAD</a:t>
-            </a:r>
-            <a:endParaRPr lang="en-US" sz="1100" dirty="0"/>
-          </a:p>
-        </p:txBody>
-      </p:sp>
-      <p:sp>
-        <p:nvSpPr>
-          <p:cNvPr id="6" name="Text 3"/>
-          <p:cNvSpPr txBox="1"/>
-          <p:nvPr/>
-        </p:nvSpPr>
-        <p:spPr>
-          <a:xfrm>
-            <a:off x="658368" y="1847088"/>
-            <a:ext cx="5138928" cy="3429000"/>
-          </a:xfrm>
-          <a:prstGeom prst="rect">
-            <a:avLst/>
-          </a:prstGeom>
-          <a:noFill/>
-          <a:ln/>
-        </p:spPr>
-        <p:txBody>
-          <a:bodyPr wrap="square" lIns="0" tIns="0" rIns="0" bIns="0" rtlCol="0" anchor="t"/>
-          <a:lstStyle/>
-          <a:p>
-            <a:pPr indent="0" marL="0">
-              <a:spcAft>
-                <a:spcPts val="1000"/>
-              </a:spcAft>
-              <a:buNone/>
-            </a:pPr>
-            <a:r>
-              <a:rPr lang="en-US" sz="1500" b="1" dirty="0">
-                <a:solidFill>
-                  <a:srgbClr val="B5651D"/>
-                </a:solidFill>
-              </a:rPr>
-              <a:t>▪  </a:t>
-            </a:r>
-            <a:pPr indent="0" marL="0">
-              <a:spcAft>
-                <a:spcPts val="1000"/>
-              </a:spcAft>
-              <a:buNone/>
-            </a:pPr>
-            <a:r>
-              <a:rPr lang="en-US" sz="1500" dirty="0">
-                <a:solidFill>
-                  <a:srgbClr val="272425"/>
-                </a:solidFill>
-              </a:rPr>
-              <a:t>Falta un piloto real con usuarios no técnicos durante varias semanas</a:t>
+              <a:t>Abierto: licencia MIT; los datos son archivos de texto que se leen sin pm-method</a:t>
             </a:r>
             <a:endParaRPr lang="en-US" sz="1500" dirty="0"/>
-          </a:p>
-          <a:p>
-            <a:pPr indent="0" marL="0">
-              <a:spcAft>
-                <a:spcPts val="1000"/>
-              </a:spcAft>
-              <a:buNone/>
-            </a:pPr>
-            <a:r>
-              <a:rPr lang="en-US" sz="1500" b="1" dirty="0">
-                <a:solidFill>
-                  <a:srgbClr val="B5651D"/>
-                </a:solidFill>
-              </a:rPr>
-              <a:t>▪  </a:t>
-            </a:r>
-            <a:pPr indent="0" marL="0">
-              <a:spcAft>
-                <a:spcPts val="1000"/>
-              </a:spcAft>
-              <a:buNone/>
-            </a:pPr>
-            <a:r>
-              <a:rPr lang="en-US" sz="1500" dirty="0">
-                <a:solidFill>
-                  <a:srgbClr val="272425"/>
-                </a:solidFill>
-              </a:rPr>
-              <a:t>Los conectores con herramientas externas están documentados, pero no se probaron en vivo con servicios reales</a:t>
-            </a:r>
-            <a:endParaRPr lang="en-US" sz="1500" dirty="0"/>
-          </a:p>
-          <a:p>
-            <a:pPr indent="0" marL="0">
-              <a:spcAft>
-                <a:spcPts val="1000"/>
-              </a:spcAft>
-              <a:buNone/>
-            </a:pPr>
-            <a:r>
-              <a:rPr lang="en-US" sz="1500" b="1" dirty="0">
-                <a:solidFill>
-                  <a:srgbClr val="B5651D"/>
-                </a:solidFill>
-              </a:rPr>
-              <a:t>▪  </a:t>
-            </a:r>
-            <a:pPr indent="0" marL="0">
-              <a:spcAft>
-                <a:spcPts val="1000"/>
-              </a:spcAft>
-              <a:buNone/>
-            </a:pPr>
-            <a:r>
-              <a:rPr lang="en-US" sz="1500" dirty="0">
-                <a:solidFill>
-                  <a:srgbClr val="272425"/>
-                </a:solidFill>
-              </a:rPr>
-              <a:t>El asistente puede interpretar distinto una frase: los comandos fijos son la vía segura</a:t>
-            </a:r>
-            <a:endParaRPr lang="en-US" sz="1500" dirty="0"/>
-          </a:p>
-          <a:p>
-            <a:pPr indent="0" marL="0">
-              <a:spcAft>
-                <a:spcPts val="1000"/>
-              </a:spcAft>
-              <a:buNone/>
-            </a:pPr>
-            <a:r>
-              <a:rPr lang="en-US" sz="1500" b="1" dirty="0">
-                <a:solidFill>
-                  <a:srgbClr val="B5651D"/>
-                </a:solidFill>
-              </a:rPr>
-              <a:t>▪  </a:t>
-            </a:r>
-            <a:pPr indent="0" marL="0">
-              <a:spcAft>
-                <a:spcPts val="1000"/>
-              </a:spcAft>
-              <a:buNone/>
-            </a:pPr>
-            <a:r>
-              <a:rPr lang="en-US" sz="1500" dirty="0">
-                <a:solidFill>
-                  <a:srgbClr val="272425"/>
-                </a:solidFill>
-              </a:rPr>
-              <a:t>No reemplaza el criterio profesional: las decisiones son siempre de una persona</a:t>
-            </a:r>
-            <a:endParaRPr lang="en-US" sz="1500" dirty="0"/>
-          </a:p>
-        </p:txBody>
-      </p:sp>
-      <p:sp>
-        <p:nvSpPr>
-          <p:cNvPr id="7" name="Shape 4"/>
-          <p:cNvSpPr/>
-          <p:nvPr/>
-        </p:nvSpPr>
-        <p:spPr>
-          <a:xfrm>
-            <a:off x="6190488" y="1298448"/>
-            <a:ext cx="5541264" cy="4114800"/>
-          </a:xfrm>
-          <a:prstGeom prst="roundRect">
-            <a:avLst>
-              <a:gd name="adj" fmla="val 1778"/>
-            </a:avLst>
-          </a:prstGeom>
-          <a:solidFill>
-            <a:srgbClr val="E9F1F8"/>
-          </a:solidFill>
-          <a:ln w="9525">
-            <a:solidFill>
-              <a:srgbClr val="E9F1F8"/>
-            </a:solidFill>
-            <a:prstDash val="solid"/>
-          </a:ln>
-        </p:spPr>
-      </p:sp>
-      <p:sp>
-        <p:nvSpPr>
-          <p:cNvPr id="8" name="Text 5"/>
-          <p:cNvSpPr txBox="1"/>
-          <p:nvPr/>
-        </p:nvSpPr>
-        <p:spPr>
-          <a:xfrm>
-            <a:off x="6391656" y="1463040"/>
-            <a:ext cx="5175504" cy="256032"/>
-          </a:xfrm>
-          <a:prstGeom prst="rect">
-            <a:avLst/>
-          </a:prstGeom>
-          <a:noFill/>
-          <a:ln/>
-        </p:spPr>
-        <p:txBody>
-          <a:bodyPr wrap="square" lIns="0" tIns="0" rIns="0" bIns="0" rtlCol="0" anchor="t"/>
-          <a:lstStyle/>
-          <a:p>
-            <a:pPr indent="0" marL="0">
-              <a:buNone/>
-            </a:pPr>
-            <a:r>
-              <a:rPr lang="en-US" sz="1100" b="1" spc="100" kern="0" dirty="0">
-                <a:solidFill>
-                  <a:srgbClr val="2B6A9A"/>
-                </a:solidFill>
-              </a:rPr>
-              <a:t>MATERIAL LISTO PARA APRENDER: CINCO CASOS DE PRÁCTICA</a:t>
-            </a:r>
-            <a:endParaRPr lang="en-US" sz="1100" dirty="0"/>
-          </a:p>
-        </p:txBody>
-      </p:sp>
-      <p:sp>
-        <p:nvSpPr>
-          <p:cNvPr id="9" name="Shape 6"/>
-          <p:cNvSpPr/>
-          <p:nvPr/>
-        </p:nvSpPr>
-        <p:spPr>
-          <a:xfrm>
-            <a:off x="6391656" y="1901952"/>
-            <a:ext cx="420624" cy="420624"/>
-          </a:xfrm>
-          <a:prstGeom prst="ellipse">
-            <a:avLst/>
-          </a:prstGeom>
-          <a:solidFill>
-            <a:srgbClr val="17324D"/>
-          </a:solidFill>
-          <a:ln w="12700">
-            <a:solidFill>
-              <a:srgbClr val="17324D"/>
-            </a:solidFill>
-            <a:prstDash val="solid"/>
-          </a:ln>
-        </p:spPr>
-      </p:sp>
-      <p:sp>
-        <p:nvSpPr>
-          <p:cNvPr id="10" name="Text 7"/>
-          <p:cNvSpPr txBox="1"/>
-          <p:nvPr/>
-        </p:nvSpPr>
-        <p:spPr>
-          <a:xfrm>
-            <a:off x="6391656" y="1901952"/>
-            <a:ext cx="420624" cy="420624"/>
-          </a:xfrm>
-          <a:prstGeom prst="rect">
-            <a:avLst/>
-          </a:prstGeom>
-          <a:noFill/>
-          <a:ln/>
-        </p:spPr>
-        <p:txBody>
-          <a:bodyPr wrap="square" lIns="0" tIns="0" rIns="0" bIns="0" rtlCol="0" anchor="ctr"/>
-          <a:lstStyle/>
-          <a:p>
-            <a:pPr algn="ctr" indent="0" marL="0">
-              <a:buNone/>
-            </a:pPr>
-            <a:r>
-              <a:rPr lang="en-US" sz="1400" b="1" dirty="0">
-                <a:solidFill>
-                  <a:srgbClr val="FFFFFF"/>
-                </a:solidFill>
-              </a:rPr>
-              <a:t>1</a:t>
-            </a:r>
-            <a:endParaRPr lang="en-US" sz="1400" dirty="0"/>
-          </a:p>
-        </p:txBody>
-      </p:sp>
-      <p:sp>
-        <p:nvSpPr>
-          <p:cNvPr id="11" name="Text 8"/>
-          <p:cNvSpPr txBox="1"/>
-          <p:nvPr/>
-        </p:nvSpPr>
-        <p:spPr>
-          <a:xfrm>
-            <a:off x="6958584" y="1865376"/>
-            <a:ext cx="4581144" cy="292608"/>
-          </a:xfrm>
-          <a:prstGeom prst="rect">
-            <a:avLst/>
-          </a:prstGeom>
-          <a:noFill/>
-          <a:ln/>
-        </p:spPr>
-        <p:txBody>
-          <a:bodyPr wrap="square" lIns="0" tIns="0" rIns="0" bIns="0" rtlCol="0" anchor="t"/>
-          <a:lstStyle/>
-          <a:p>
-            <a:pPr indent="0" marL="0">
-              <a:buNone/>
-            </a:pPr>
-            <a:r>
-              <a:rPr lang="en-US" sz="1500" b="1" dirty="0">
-                <a:solidFill>
-                  <a:srgbClr val="17324D"/>
-                </a:solidFill>
-              </a:rPr>
-              <a:t>Anticipar lo que puede salir mal</a:t>
-            </a:r>
-            <a:endParaRPr lang="en-US" sz="1500" dirty="0"/>
-          </a:p>
-        </p:txBody>
-      </p:sp>
-      <p:sp>
-        <p:nvSpPr>
-          <p:cNvPr id="12" name="Text 9"/>
-          <p:cNvSpPr txBox="1"/>
-          <p:nvPr/>
-        </p:nvSpPr>
-        <p:spPr>
-          <a:xfrm>
-            <a:off x="6958584" y="2157984"/>
-            <a:ext cx="4581144" cy="237744"/>
-          </a:xfrm>
-          <a:prstGeom prst="rect">
-            <a:avLst/>
-          </a:prstGeom>
-          <a:noFill/>
-          <a:ln/>
-        </p:spPr>
-        <p:txBody>
-          <a:bodyPr wrap="square" lIns="0" tIns="0" rIns="0" bIns="0" rtlCol="0" anchor="t"/>
-          <a:lstStyle/>
-          <a:p>
-            <a:pPr indent="0" marL="0">
-              <a:buNone/>
-            </a:pPr>
-            <a:r>
-              <a:rPr lang="en-US" sz="1200" i="1" dirty="0">
-                <a:solidFill>
-                  <a:srgbClr val="696969"/>
-                </a:solidFill>
-              </a:rPr>
-              <a:t>riesgos · caso E2E-1</a:t>
-            </a:r>
-            <a:endParaRPr lang="en-US" sz="1200" dirty="0"/>
-          </a:p>
-        </p:txBody>
-      </p:sp>
-      <p:sp>
-        <p:nvSpPr>
-          <p:cNvPr id="13" name="Shape 10"/>
-          <p:cNvSpPr/>
-          <p:nvPr/>
-        </p:nvSpPr>
-        <p:spPr>
-          <a:xfrm>
-            <a:off x="6391656" y="2587752"/>
-            <a:ext cx="420624" cy="420624"/>
-          </a:xfrm>
-          <a:prstGeom prst="ellipse">
-            <a:avLst/>
-          </a:prstGeom>
-          <a:solidFill>
-            <a:srgbClr val="17324D"/>
-          </a:solidFill>
-          <a:ln w="12700">
-            <a:solidFill>
-              <a:srgbClr val="17324D"/>
-            </a:solidFill>
-            <a:prstDash val="solid"/>
-          </a:ln>
-        </p:spPr>
-      </p:sp>
-      <p:sp>
-        <p:nvSpPr>
-          <p:cNvPr id="14" name="Text 11"/>
-          <p:cNvSpPr txBox="1"/>
-          <p:nvPr/>
-        </p:nvSpPr>
-        <p:spPr>
-          <a:xfrm>
-            <a:off x="6391656" y="2587752"/>
-            <a:ext cx="420624" cy="420624"/>
-          </a:xfrm>
-          <a:prstGeom prst="rect">
-            <a:avLst/>
-          </a:prstGeom>
-          <a:noFill/>
-          <a:ln/>
-        </p:spPr>
-        <p:txBody>
-          <a:bodyPr wrap="square" lIns="0" tIns="0" rIns="0" bIns="0" rtlCol="0" anchor="ctr"/>
-          <a:lstStyle/>
-          <a:p>
-            <a:pPr algn="ctr" indent="0" marL="0">
-              <a:buNone/>
-            </a:pPr>
-            <a:r>
-              <a:rPr lang="en-US" sz="1400" b="1" dirty="0">
-                <a:solidFill>
-                  <a:srgbClr val="FFFFFF"/>
-                </a:solidFill>
-              </a:rPr>
-              <a:t>2</a:t>
-            </a:r>
-            <a:endParaRPr lang="en-US" sz="1400" dirty="0"/>
-          </a:p>
-        </p:txBody>
-      </p:sp>
-      <p:sp>
-        <p:nvSpPr>
-          <p:cNvPr id="15" name="Text 12"/>
-          <p:cNvSpPr txBox="1"/>
-          <p:nvPr/>
-        </p:nvSpPr>
-        <p:spPr>
-          <a:xfrm>
-            <a:off x="6958584" y="2551176"/>
-            <a:ext cx="4581144" cy="292608"/>
-          </a:xfrm>
-          <a:prstGeom prst="rect">
-            <a:avLst/>
-          </a:prstGeom>
-          <a:noFill/>
-          <a:ln/>
-        </p:spPr>
-        <p:txBody>
-          <a:bodyPr wrap="square" lIns="0" tIns="0" rIns="0" bIns="0" rtlCol="0" anchor="t"/>
-          <a:lstStyle/>
-          <a:p>
-            <a:pPr indent="0" marL="0">
-              <a:buNone/>
-            </a:pPr>
-            <a:r>
-              <a:rPr lang="en-US" sz="1500" b="1" dirty="0">
-                <a:solidFill>
-                  <a:srgbClr val="17324D"/>
-                </a:solidFill>
-              </a:rPr>
-              <a:t>Cambiar el plan sin perder el control</a:t>
-            </a:r>
-            <a:endParaRPr lang="en-US" sz="1500" dirty="0"/>
-          </a:p>
-        </p:txBody>
-      </p:sp>
-      <p:sp>
-        <p:nvSpPr>
-          <p:cNvPr id="16" name="Text 13"/>
-          <p:cNvSpPr txBox="1"/>
-          <p:nvPr/>
-        </p:nvSpPr>
-        <p:spPr>
-          <a:xfrm>
-            <a:off x="6958584" y="2843784"/>
-            <a:ext cx="4581144" cy="237744"/>
-          </a:xfrm>
-          <a:prstGeom prst="rect">
-            <a:avLst/>
-          </a:prstGeom>
-          <a:noFill/>
-          <a:ln/>
-        </p:spPr>
-        <p:txBody>
-          <a:bodyPr wrap="square" lIns="0" tIns="0" rIns="0" bIns="0" rtlCol="0" anchor="t"/>
-          <a:lstStyle/>
-          <a:p>
-            <a:pPr indent="0" marL="0">
-              <a:buNone/>
-            </a:pPr>
-            <a:r>
-              <a:rPr lang="en-US" sz="1200" i="1" dirty="0">
-                <a:solidFill>
-                  <a:srgbClr val="696969"/>
-                </a:solidFill>
-              </a:rPr>
-              <a:t>alcance y cambios · caso E2E-2</a:t>
-            </a:r>
-            <a:endParaRPr lang="en-US" sz="1200" dirty="0"/>
-          </a:p>
-        </p:txBody>
-      </p:sp>
-      <p:sp>
-        <p:nvSpPr>
-          <p:cNvPr id="17" name="Shape 14"/>
-          <p:cNvSpPr/>
-          <p:nvPr/>
-        </p:nvSpPr>
-        <p:spPr>
-          <a:xfrm>
-            <a:off x="6391656" y="3273552"/>
-            <a:ext cx="420624" cy="420624"/>
-          </a:xfrm>
-          <a:prstGeom prst="ellipse">
-            <a:avLst/>
-          </a:prstGeom>
-          <a:solidFill>
-            <a:srgbClr val="17324D"/>
-          </a:solidFill>
-          <a:ln w="12700">
-            <a:solidFill>
-              <a:srgbClr val="17324D"/>
-            </a:solidFill>
-            <a:prstDash val="solid"/>
-          </a:ln>
-        </p:spPr>
-      </p:sp>
-      <p:sp>
-        <p:nvSpPr>
-          <p:cNvPr id="18" name="Text 15"/>
-          <p:cNvSpPr txBox="1"/>
-          <p:nvPr/>
-        </p:nvSpPr>
-        <p:spPr>
-          <a:xfrm>
-            <a:off x="6391656" y="3273552"/>
-            <a:ext cx="420624" cy="420624"/>
-          </a:xfrm>
-          <a:prstGeom prst="rect">
-            <a:avLst/>
-          </a:prstGeom>
-          <a:noFill/>
-          <a:ln/>
-        </p:spPr>
-        <p:txBody>
-          <a:bodyPr wrap="square" lIns="0" tIns="0" rIns="0" bIns="0" rtlCol="0" anchor="ctr"/>
-          <a:lstStyle/>
-          <a:p>
-            <a:pPr algn="ctr" indent="0" marL="0">
-              <a:buNone/>
-            </a:pPr>
-            <a:r>
-              <a:rPr lang="en-US" sz="1400" b="1" dirty="0">
-                <a:solidFill>
-                  <a:srgbClr val="FFFFFF"/>
-                </a:solidFill>
-              </a:rPr>
-              <a:t>3</a:t>
-            </a:r>
-            <a:endParaRPr lang="en-US" sz="1400" dirty="0"/>
-          </a:p>
-        </p:txBody>
-      </p:sp>
-      <p:sp>
-        <p:nvSpPr>
-          <p:cNvPr id="19" name="Text 16"/>
-          <p:cNvSpPr txBox="1"/>
-          <p:nvPr/>
-        </p:nvSpPr>
-        <p:spPr>
-          <a:xfrm>
-            <a:off x="6958584" y="3236976"/>
-            <a:ext cx="4581144" cy="292608"/>
-          </a:xfrm>
-          <a:prstGeom prst="rect">
-            <a:avLst/>
-          </a:prstGeom>
-          <a:noFill/>
-          <a:ln/>
-        </p:spPr>
-        <p:txBody>
-          <a:bodyPr wrap="square" lIns="0" tIns="0" rIns="0" bIns="0" rtlCol="0" anchor="t"/>
-          <a:lstStyle/>
-          <a:p>
-            <a:pPr indent="0" marL="0">
-              <a:buNone/>
-            </a:pPr>
-            <a:r>
-              <a:rPr lang="en-US" sz="1500" b="1" dirty="0">
-                <a:solidFill>
-                  <a:srgbClr val="17324D"/>
-                </a:solidFill>
-              </a:rPr>
-              <a:t>Informar a cada persona lo que necesita</a:t>
-            </a:r>
-            <a:endParaRPr lang="en-US" sz="1500" dirty="0"/>
-          </a:p>
-        </p:txBody>
-      </p:sp>
-      <p:sp>
-        <p:nvSpPr>
-          <p:cNvPr id="20" name="Text 17"/>
-          <p:cNvSpPr txBox="1"/>
-          <p:nvPr/>
-        </p:nvSpPr>
-        <p:spPr>
-          <a:xfrm>
-            <a:off x="6958584" y="3529584"/>
-            <a:ext cx="4581144" cy="237744"/>
-          </a:xfrm>
-          <a:prstGeom prst="rect">
-            <a:avLst/>
-          </a:prstGeom>
-          <a:noFill/>
-          <a:ln/>
-        </p:spPr>
-        <p:txBody>
-          <a:bodyPr wrap="square" lIns="0" tIns="0" rIns="0" bIns="0" rtlCol="0" anchor="t"/>
-          <a:lstStyle/>
-          <a:p>
-            <a:pPr indent="0" marL="0">
-              <a:buNone/>
-            </a:pPr>
-            <a:r>
-              <a:rPr lang="en-US" sz="1200" i="1" dirty="0">
-                <a:solidFill>
-                  <a:srgbClr val="696969"/>
-                </a:solidFill>
-              </a:rPr>
-              <a:t>interesados y avance · caso E2E-3</a:t>
-            </a:r>
-            <a:endParaRPr lang="en-US" sz="1200" dirty="0"/>
-          </a:p>
-        </p:txBody>
-      </p:sp>
-      <p:sp>
-        <p:nvSpPr>
-          <p:cNvPr id="21" name="Shape 18"/>
-          <p:cNvSpPr/>
-          <p:nvPr/>
-        </p:nvSpPr>
-        <p:spPr>
-          <a:xfrm>
-            <a:off x="6391656" y="3959352"/>
-            <a:ext cx="420624" cy="420624"/>
-          </a:xfrm>
-          <a:prstGeom prst="ellipse">
-            <a:avLst/>
-          </a:prstGeom>
-          <a:solidFill>
-            <a:srgbClr val="17324D"/>
-          </a:solidFill>
-          <a:ln w="12700">
-            <a:solidFill>
-              <a:srgbClr val="17324D"/>
-            </a:solidFill>
-            <a:prstDash val="solid"/>
-          </a:ln>
-        </p:spPr>
-      </p:sp>
-      <p:sp>
-        <p:nvSpPr>
-          <p:cNvPr id="22" name="Text 19"/>
-          <p:cNvSpPr txBox="1"/>
-          <p:nvPr/>
-        </p:nvSpPr>
-        <p:spPr>
-          <a:xfrm>
-            <a:off x="6391656" y="3959352"/>
-            <a:ext cx="420624" cy="420624"/>
-          </a:xfrm>
-          <a:prstGeom prst="rect">
-            <a:avLst/>
-          </a:prstGeom>
-          <a:noFill/>
-          <a:ln/>
-        </p:spPr>
-        <p:txBody>
-          <a:bodyPr wrap="square" lIns="0" tIns="0" rIns="0" bIns="0" rtlCol="0" anchor="ctr"/>
-          <a:lstStyle/>
-          <a:p>
-            <a:pPr algn="ctr" indent="0" marL="0">
-              <a:buNone/>
-            </a:pPr>
-            <a:r>
-              <a:rPr lang="en-US" sz="1400" b="1" dirty="0">
-                <a:solidFill>
-                  <a:srgbClr val="FFFFFF"/>
-                </a:solidFill>
-              </a:rPr>
-              <a:t>4</a:t>
-            </a:r>
-            <a:endParaRPr lang="en-US" sz="1400" dirty="0"/>
-          </a:p>
-        </p:txBody>
-      </p:sp>
-      <p:sp>
-        <p:nvSpPr>
-          <p:cNvPr id="23" name="Text 20"/>
-          <p:cNvSpPr txBox="1"/>
-          <p:nvPr/>
-        </p:nvSpPr>
-        <p:spPr>
-          <a:xfrm>
-            <a:off x="6958584" y="3922776"/>
-            <a:ext cx="4581144" cy="292608"/>
-          </a:xfrm>
-          <a:prstGeom prst="rect">
-            <a:avLst/>
-          </a:prstGeom>
-          <a:noFill/>
-          <a:ln/>
-        </p:spPr>
-        <p:txBody>
-          <a:bodyPr wrap="square" lIns="0" tIns="0" rIns="0" bIns="0" rtlCol="0" anchor="t"/>
-          <a:lstStyle/>
-          <a:p>
-            <a:pPr indent="0" marL="0">
-              <a:buNone/>
-            </a:pPr>
-            <a:r>
-              <a:rPr lang="en-US" sz="1500" b="1" dirty="0">
-                <a:solidFill>
-                  <a:srgbClr val="17324D"/>
-                </a:solidFill>
-              </a:rPr>
-              <a:t>Construir un producto de software con control</a:t>
-            </a:r>
-            <a:endParaRPr lang="en-US" sz="1500" dirty="0"/>
-          </a:p>
-        </p:txBody>
-      </p:sp>
-      <p:sp>
-        <p:nvSpPr>
-          <p:cNvPr id="24" name="Text 21"/>
-          <p:cNvSpPr txBox="1"/>
-          <p:nvPr/>
-        </p:nvSpPr>
-        <p:spPr>
-          <a:xfrm>
-            <a:off x="6958584" y="4215384"/>
-            <a:ext cx="4581144" cy="237744"/>
-          </a:xfrm>
-          <a:prstGeom prst="rect">
-            <a:avLst/>
-          </a:prstGeom>
-          <a:noFill/>
-          <a:ln/>
-        </p:spPr>
-        <p:txBody>
-          <a:bodyPr wrap="square" lIns="0" tIns="0" rIns="0" bIns="0" rtlCol="0" anchor="t"/>
-          <a:lstStyle/>
-          <a:p>
-            <a:pPr indent="0" marL="0">
-              <a:buNone/>
-            </a:pPr>
-            <a:r>
-              <a:rPr lang="en-US" sz="1200" i="1" dirty="0">
-                <a:solidFill>
-                  <a:srgbClr val="696969"/>
-                </a:solidFill>
-              </a:rPr>
-              <a:t>producto con IA · caso E2E-4</a:t>
-            </a:r>
-            <a:endParaRPr lang="en-US" sz="1200" dirty="0"/>
-          </a:p>
-        </p:txBody>
-      </p:sp>
-      <p:sp>
-        <p:nvSpPr>
-          <p:cNvPr id="25" name="Shape 22"/>
-          <p:cNvSpPr/>
-          <p:nvPr/>
-        </p:nvSpPr>
-        <p:spPr>
-          <a:xfrm>
-            <a:off x="6391656" y="4645152"/>
-            <a:ext cx="420624" cy="420624"/>
-          </a:xfrm>
-          <a:prstGeom prst="ellipse">
-            <a:avLst/>
-          </a:prstGeom>
-          <a:solidFill>
-            <a:srgbClr val="17324D"/>
-          </a:solidFill>
-          <a:ln w="12700">
-            <a:solidFill>
-              <a:srgbClr val="17324D"/>
-            </a:solidFill>
-            <a:prstDash val="solid"/>
-          </a:ln>
-        </p:spPr>
-      </p:sp>
-      <p:sp>
-        <p:nvSpPr>
-          <p:cNvPr id="26" name="Text 23"/>
-          <p:cNvSpPr txBox="1"/>
-          <p:nvPr/>
-        </p:nvSpPr>
-        <p:spPr>
-          <a:xfrm>
-            <a:off x="6391656" y="4645152"/>
-            <a:ext cx="420624" cy="420624"/>
-          </a:xfrm>
-          <a:prstGeom prst="rect">
-            <a:avLst/>
-          </a:prstGeom>
-          <a:noFill/>
-          <a:ln/>
-        </p:spPr>
-        <p:txBody>
-          <a:bodyPr wrap="square" lIns="0" tIns="0" rIns="0" bIns="0" rtlCol="0" anchor="ctr"/>
-          <a:lstStyle/>
-          <a:p>
-            <a:pPr algn="ctr" indent="0" marL="0">
-              <a:buNone/>
-            </a:pPr>
-            <a:r>
-              <a:rPr lang="en-US" sz="1400" b="1" dirty="0">
-                <a:solidFill>
-                  <a:srgbClr val="FFFFFF"/>
-                </a:solidFill>
-              </a:rPr>
-              <a:t>5</a:t>
-            </a:r>
-            <a:endParaRPr lang="en-US" sz="1400" dirty="0"/>
-          </a:p>
-        </p:txBody>
-      </p:sp>
-      <p:sp>
-        <p:nvSpPr>
-          <p:cNvPr id="27" name="Text 24"/>
-          <p:cNvSpPr txBox="1"/>
-          <p:nvPr/>
-        </p:nvSpPr>
-        <p:spPr>
-          <a:xfrm>
-            <a:off x="6958584" y="4608576"/>
-            <a:ext cx="4581144" cy="292608"/>
-          </a:xfrm>
-          <a:prstGeom prst="rect">
-            <a:avLst/>
-          </a:prstGeom>
-          <a:noFill/>
-          <a:ln/>
-        </p:spPr>
-        <p:txBody>
-          <a:bodyPr wrap="square" lIns="0" tIns="0" rIns="0" bIns="0" rtlCol="0" anchor="t"/>
-          <a:lstStyle/>
-          <a:p>
-            <a:pPr indent="0" marL="0">
-              <a:buNone/>
-            </a:pPr>
-            <a:r>
-              <a:rPr lang="en-US" sz="1500" b="1" dirty="0">
-                <a:solidFill>
-                  <a:srgbClr val="17324D"/>
-                </a:solidFill>
-              </a:rPr>
-              <a:t>Decidir si una idea vale la pena antes de invertir</a:t>
-            </a:r>
-            <a:endParaRPr lang="en-US" sz="1500" dirty="0"/>
-          </a:p>
-        </p:txBody>
-      </p:sp>
-      <p:sp>
-        <p:nvSpPr>
-          <p:cNvPr id="28" name="Text 25"/>
-          <p:cNvSpPr txBox="1"/>
-          <p:nvPr/>
-        </p:nvSpPr>
-        <p:spPr>
-          <a:xfrm>
-            <a:off x="6958584" y="4901184"/>
-            <a:ext cx="4581144" cy="237744"/>
-          </a:xfrm>
-          <a:prstGeom prst="rect">
-            <a:avLst/>
-          </a:prstGeom>
-          <a:noFill/>
-          <a:ln/>
-        </p:spPr>
-        <p:txBody>
-          <a:bodyPr wrap="square" lIns="0" tIns="0" rIns="0" bIns="0" rtlCol="0" anchor="t"/>
-          <a:lstStyle/>
-          <a:p>
-            <a:pPr indent="0" marL="0">
-              <a:buNone/>
-            </a:pPr>
-            <a:r>
-              <a:rPr lang="en-US" sz="1200" i="1" dirty="0">
-                <a:solidFill>
-                  <a:srgbClr val="696969"/>
-                </a:solidFill>
-              </a:rPr>
-              <a:t>de la idea al proyecto · caso E2E-5</a:t>
-            </a:r>
-            <a:endParaRPr lang="en-US" sz="1200" dirty="0"/>
-          </a:p>
-        </p:txBody>
-      </p:sp>
-      <p:sp>
-        <p:nvSpPr>
-          <p:cNvPr id="29" name="Shape 26"/>
-          <p:cNvSpPr/>
-          <p:nvPr/>
-        </p:nvSpPr>
-        <p:spPr>
-          <a:xfrm>
-            <a:off x="457200" y="5559552"/>
-            <a:ext cx="11274552" cy="676656"/>
-          </a:xfrm>
-          <a:prstGeom prst="roundRect">
-            <a:avLst>
-              <a:gd name="adj" fmla="val 10811"/>
-            </a:avLst>
-          </a:prstGeom>
-          <a:solidFill>
-            <a:srgbClr val="FBF1E6"/>
-          </a:solidFill>
-          <a:ln w="9525">
-            <a:solidFill>
-              <a:srgbClr val="FBF1E6"/>
-            </a:solidFill>
-            <a:prstDash val="solid"/>
-          </a:ln>
-        </p:spPr>
-      </p:sp>
-      <p:sp>
-        <p:nvSpPr>
-          <p:cNvPr id="30" name="Text 27"/>
-          <p:cNvSpPr txBox="1"/>
-          <p:nvPr/>
-        </p:nvSpPr>
-        <p:spPr>
-          <a:xfrm>
-            <a:off x="685800" y="5559552"/>
-            <a:ext cx="10881360" cy="676656"/>
-          </a:xfrm>
-          <a:prstGeom prst="rect">
-            <a:avLst/>
-          </a:prstGeom>
-          <a:noFill/>
-          <a:ln/>
-        </p:spPr>
-        <p:txBody>
-          <a:bodyPr wrap="square" lIns="0" tIns="0" rIns="0" bIns="0" rtlCol="0" anchor="ctr"/>
-          <a:lstStyle/>
-          <a:p>
-            <a:pPr indent="0" marL="0">
-              <a:buNone/>
-            </a:pPr>
-            <a:r>
-              <a:rPr lang="en-US" sz="1600" b="1" dirty="0">
-                <a:solidFill>
-                  <a:srgbClr val="B5651D"/>
-                </a:solidFill>
-              </a:rPr>
-              <a:t>Siguiente paso para IEEE: un piloto de formación de 4 a 6 sesiones (detalle en la presentación de resumen)</a:t>
-            </a:r>
-            <a:endParaRPr lang="en-US" sz="1600" dirty="0"/>
           </a:p>
         </p:txBody>
       </p:sp>

</xml_diff>